<commit_message>
Retake the git log screenshot and correct the deck text
</commit_message>
<xml_diff>
--- a/docs/PlaceTrack-Capstone.pptx
+++ b/docs/PlaceTrack-Capstone.pptx
@@ -121,41 +121,41 @@
   <p:extLst>
     <p:ext uri="{521415D9-36F7-43E2-AB2F-B90AF26B5E84}">
       <p14:sectionLst xmlns:p14="http://schemas.microsoft.com/office/powerpoint/2010/main">
-        <p14:section name="Intro" id="{4c351e2c-de79-2329-6258-09c6a54c9ab8}">
+        <p14:section name="Intro" id="{dc9b2b9a-31c0-085b-7fca-0d40615e358c}">
           <p14:sldIdLst>
             <p14:sldId id="256"/>
             <p14:sldId id="257"/>
           </p14:sldIdLst>
         </p14:section>
-        <p14:section name="App and tests" id="{b6844a18-225e-b2e9-dc49-4e8db8ea0b0a}">
+        <p14:section name="App and tests" id="{1f3c6977-92a9-6b64-cb97-b96b5efdca9a}">
           <p14:sldIdLst>
             <p14:sldId id="258"/>
             <p14:sldId id="259"/>
             <p14:sldId id="260"/>
           </p14:sldIdLst>
         </p14:section>
-        <p14:section name="Containers and CI" id="{1364cf3a-c51e-c612-7e2f-1a08065e1575}">
+        <p14:section name="Containers and CI" id="{71744e8d-4e19-306d-d9fe-c2976435a122}">
           <p14:sldIdLst>
             <p14:sldId id="261"/>
             <p14:sldId id="262"/>
             <p14:sldId id="263"/>
           </p14:sldIdLst>
         </p14:section>
-        <p14:section name="Infrastructure" id="{e893d929-c364-d58e-a4e1-7c3743984456}">
+        <p14:section name="Infrastructure" id="{23e55b49-0b84-680b-eea9-3f9b4e149220}">
           <p14:sldIdLst>
             <p14:sldId id="264"/>
             <p14:sldId id="265"/>
             <p14:sldId id="266"/>
           </p14:sldIdLst>
         </p14:section>
-        <p14:section name="Operations" id="{ae768178-d01c-e8c0-db9e-fbce8245f85a}">
+        <p14:section name="Operations" id="{5848879c-e9bc-c339-eb5e-ecd21f7578cd}">
           <p14:sldIdLst>
             <p14:sldId id="267"/>
             <p14:sldId id="268"/>
             <p14:sldId id="269"/>
           </p14:sldIdLst>
         </p14:section>
-        <p14:section name="Close" id="{3e938075-3f02-5146-63da-aa83bef81255}">
+        <p14:section name="Close" id="{251b0cd2-c299-2791-f39f-16a5b04bed40}">
           <p14:sldIdLst>
             <p14:sldId id="270"/>
           </p14:sldIdLst>
@@ -1092,7 +1092,7 @@
           <a:p>
             <a:r>
               <a:rPr lang="en-US" dirty="0"/>
-              <a:t>Four things I will remember. A passing build is not a secure build: Trivy failed my first images and I had to fix real vulnerabilities. nginx resolves upstream names once at startup, which caused a crash loop until I used a runtime resolver. Running does not mean ready, and ready does not mean reachable. And secrets are generated at deploy time, never committed. Thank you.</a:t>
+              <a:t>Four things I will remember. A passing build is not a secure build: Trivy failed my first images and I had to fix real vulnerabilities. nginx resolves upstream names once at startup, which caused a crash loop until I used a runtime resolver, and a review then showed its resolver ignores search domains, so I switched to the full service DNS name and the 502 became a 200. Running does not mean ready, and ready does not mean reachable. And secrets are generated at deploy time, never committed. Thank you.</a:t>
             </a:r>
             <a:endParaRPr lang="en-US" dirty="0"/>
           </a:p>
@@ -3104,7 +3104,7 @@
                   <a:schemeClr val="tx1"/>
                 </a:solidFill>
               </a:rPr>
-              <a:t>Browser &gt; Ingress controller &gt; frontend &gt; backend &gt; Postgres</a:t>
+              <a:t>Ingress sends / to the frontend and /api to the backend, which uses Postgres</a:t>
             </a:r>
             <a:endParaRPr lang="en-US" sz="1400" dirty="0"/>
           </a:p>
@@ -3140,7 +3140,7 @@
                   <a:schemeClr val="tx1"/>
                 </a:solidFill>
               </a:rPr>
-              <a:t>Same chart works on minikube and EKS</a:t>
+              <a:t>Same chart for minikube and EKS (EKS adds a gp3 StorageClass)</a:t>
             </a:r>
             <a:endParaRPr lang="en-US" sz="1400" dirty="0"/>
           </a:p>
@@ -5248,7 +5248,7 @@
                   <a:schemeClr val="bg1"/>
                 </a:solidFill>
               </a:rPr>
-              <a:t>nginx resolves upstream names at startup; a runtime resolver fixed the crash loop</a:t>
+              <a:t>nginx needs a runtime resolver and the full Service DNS name (502 became 200)</a:t>
             </a:r>
             <a:endParaRPr lang="en-US" sz="1600" dirty="0"/>
           </a:p>
@@ -6276,7 +6276,7 @@
                   <a:schemeClr val="accent1"/>
                 </a:solidFill>
               </a:rPr>
-              <a:t>Ten graded modules, one repository: every module has real evidence from a real run.</a:t>
+              <a:t>Ten graded modules, one repository. Every screenshot is a real capture; the GitHub run and AWS apply evidence are added once they are run.</a:t>
             </a:r>
             <a:endParaRPr lang="en-US" sz="1600" dirty="0"/>
           </a:p>
@@ -6597,7 +6597,7 @@
                 <a:ea typeface="Cambria" pitchFamily="34" charset="-122"/>
                 <a:cs typeface="Cambria" pitchFamily="34" charset="-120"/>
               </a:rPr>
-              <a:t>7</a:t>
+              <a:t>6</a:t>
             </a:r>
             <a:endParaRPr lang="en-US" sz="4800" dirty="0"/>
           </a:p>
@@ -6633,7 +6633,7 @@
                   <a:schemeClr val="accent6"/>
                 </a:solidFill>
               </a:rPr>
-              <a:t>REST endpoints + health, ready, metrics</a:t>
+              <a:t>REST endpoints under /api, plus health, ready, metrics</a:t>
             </a:r>
             <a:endParaRPr lang="en-US" sz="1400" dirty="0"/>
           </a:p>
@@ -7342,7 +7342,7 @@
                 <a:ea typeface="Cambria" pitchFamily="34" charset="-122"/>
                 <a:cs typeface="Cambria" pitchFamily="34" charset="-120"/>
               </a:rPr>
-              <a:t>15</a:t>
+              <a:t>18</a:t>
             </a:r>
             <a:endParaRPr lang="en-US" sz="4800" dirty="0"/>
           </a:p>
@@ -7378,7 +7378,7 @@
                   <a:schemeClr val="accent6"/>
                 </a:solidFill>
               </a:rPr>
-              <a:t>meaningful commits</a:t>
+              <a:t>meaningful commits so far</a:t>
             </a:r>
             <a:endParaRPr lang="en-US" sz="1400" dirty="0"/>
           </a:p>
@@ -7469,7 +7469,7 @@
         <p:spPr>
           <a:xfrm>
             <a:off x="420624" y="2386584"/>
-            <a:ext cx="5594070" cy="2313432"/>
+            <a:ext cx="4670642" cy="2313432"/>
           </a:xfrm>
           <a:prstGeom prst="roundRect">
             <a:avLst>
@@ -7511,7 +7511,7 @@
         <p:spPr>
           <a:xfrm>
             <a:off x="457200" y="2423160"/>
-            <a:ext cx="5520918" cy="2240280"/>
+            <a:ext cx="4597490" cy="2240280"/>
           </a:xfrm>
           <a:prstGeom prst="rect">
             <a:avLst/>

</xml_diff>

<commit_message>
Update the deck and speaker script, retake the Trivy screenshot with the final commit hash
</commit_message>
<xml_diff>
--- a/docs/PlaceTrack-Capstone.pptx
+++ b/docs/PlaceTrack-Capstone.pptx
@@ -121,41 +121,41 @@
   <p:extLst>
     <p:ext uri="{521415D9-36F7-43E2-AB2F-B90AF26B5E84}">
       <p14:sectionLst xmlns:p14="http://schemas.microsoft.com/office/powerpoint/2010/main">
-        <p14:section name="Intro" id="{dc9b2b9a-31c0-085b-7fca-0d40615e358c}">
+        <p14:section name="Intro" id="{6dcb9cfe-6473-8e7e-e113-3129b9ed3246}">
           <p14:sldIdLst>
             <p14:sldId id="256"/>
             <p14:sldId id="257"/>
           </p14:sldIdLst>
         </p14:section>
-        <p14:section name="App and tests" id="{1f3c6977-92a9-6b64-cb97-b96b5efdca9a}">
+        <p14:section name="App and tests" id="{18c4e3aa-2d90-5649-d56b-190b89da508d}">
           <p14:sldIdLst>
             <p14:sldId id="258"/>
             <p14:sldId id="259"/>
             <p14:sldId id="260"/>
           </p14:sldIdLst>
         </p14:section>
-        <p14:section name="Containers and CI" id="{71744e8d-4e19-306d-d9fe-c2976435a122}">
+        <p14:section name="Containers and CI" id="{b2aedb7a-3dc3-f912-7bd6-9c95c7ef4244}">
           <p14:sldIdLst>
             <p14:sldId id="261"/>
             <p14:sldId id="262"/>
             <p14:sldId id="263"/>
           </p14:sldIdLst>
         </p14:section>
-        <p14:section name="Infrastructure" id="{23e55b49-0b84-680b-eea9-3f9b4e149220}">
+        <p14:section name="Infrastructure" id="{66491778-d87d-0596-2bfe-c2ff575c4086}">
           <p14:sldIdLst>
             <p14:sldId id="264"/>
             <p14:sldId id="265"/>
             <p14:sldId id="266"/>
           </p14:sldIdLst>
         </p14:section>
-        <p14:section name="Operations" id="{5848879c-e9bc-c339-eb5e-ecd21f7578cd}">
+        <p14:section name="Operations" id="{bc01beed-2b0a-281b-9be4-6faf3745e9a3}">
           <p14:sldIdLst>
             <p14:sldId id="267"/>
             <p14:sldId id="268"/>
             <p14:sldId id="269"/>
           </p14:sldIdLst>
         </p14:section>
-        <p14:section name="Close" id="{251b0cd2-c299-2791-f39f-16a5b04bed40}">
+        <p14:section name="Close" id="{da380b2e-fcf7-6d0f-963e-d5f2762a8c69}">
           <p14:sldIdLst>
             <p14:sldId id="270"/>
           </p14:sldIdLst>
@@ -564,7 +564,7 @@
           <a:p>
             <a:r>
               <a:rPr lang="en-US" dirty="0"/>
-              <a:t>Hello, I am Raghavendra. This is my DevOps capstone: PlaceTrack, a job application tracker. The app is small on purpose; the project is about everything around it - testing, containers, CI/CD, security scanning, Terraform, Kubernetes with Helm, and monitoring.</a:t>
+              <a:t>Hello, I am Raghavendra. This is my DevOps capstone: PlaceTrack, a job application tracker. The app is small on purpose. The project is everything around it: testing, containers, CI/CD, security scanning, Terraform, Kubernetes with Helm, and monitoring.</a:t>
             </a:r>
             <a:endParaRPr lang="en-US" dirty="0"/>
           </a:p>
@@ -1092,7 +1092,7 @@
           <a:p>
             <a:r>
               <a:rPr lang="en-US" dirty="0"/>
-              <a:t>Four things I will remember. A passing build is not a secure build: Trivy failed my first images and I had to fix real vulnerabilities. nginx resolves upstream names once at startup, which caused a crash loop until I used a runtime resolver, and a review then showed its resolver ignores search domains, so I switched to the full service DNS name and the 502 became a 200. Running does not mean ready, and ready does not mean reachable. And secrets are generated at deploy time, never committed. Thank you.</a:t>
+              <a:t>Four things I will remember. A passing build is not a secure build: Trivy failed my first images and I had to fix real vulnerabilities. nginx resolves upstream names once at startup, which caused a crash loop until I used a runtime resolver, and a request through the frontend service then showed that the resolver ignores search domains, so I switched to the full service DNS name and the 502 became a 200. Running does not mean ready, and ready does not mean reachable. And secrets are generated at deploy time, never committed. Thank you.</a:t>
             </a:r>
             <a:endParaRPr lang="en-US" dirty="0"/>
           </a:p>
@@ -1180,7 +1180,7 @@
           <a:p>
             <a:r>
               <a:rPr lang="en-US" dirty="0"/>
-              <a:t>PlaceTrack lets me track every job application. The interesting part is the path: code goes through GitHub Actions for tests, builds and a security scan, images go to a registry tagged with the commit, Terraform builds the AWS network and cluster, Helm deploys, and Prometheus and Grafana watch it. Each module of the course maps to one piece of this chain, and every screenshot in this deck is a real capture.</a:t>
+              <a:t>PlaceTrack lets me track every job application. Code goes through GitHub Actions for tests, builds and a security scan, images go to a registry tagged with the commit, Terraform builds the AWS network and cluster, Helm deploys, and Prometheus and Grafana watch it. Every screenshot in this deck is a real capture.</a:t>
             </a:r>
             <a:endParaRPr lang="en-US" dirty="0"/>
           </a:p>
@@ -1620,7 +1620,7 @@
           <a:p>
             <a:r>
               <a:rPr lang="en-US" dirty="0"/>
-              <a:t>The workflow runs on every push to main. It runs pytest, builds the frontend, builds both Docker images, scans them with Trivy, and only then pushes them to GitHub Container Registry, tagged with the commit SHA instead of latest. If a test fails or Trivy finds a fixable high or critical vulnerability, nothing is published. I hardened the workflow so third-party actions are pinned to exact commits and only the image job can write packages. I have not pushed the repository yet, so I ran each of these steps locally; the live run link comes after the first push.</a:t>
+              <a:t>The workflow runs on every push to main. It runs pytest, builds the frontend, builds both Docker images, scans them with Trivy, and only then pushes them to GitHub Container Registry, tagged with the commit SHA instead of latest. If a test fails or Trivy finds a fixable high or critical vulnerability, nothing is published. The actions are pinned to exact commits and only the image job can write packages. I have not pushed the repository yet, so I ran each of these steps locally; the live run link comes after the first push.</a:t>
             </a:r>
             <a:endParaRPr lang="en-US" dirty="0"/>
           </a:p>
@@ -1708,7 +1708,7 @@
           <a:p>
             <a:r>
               <a:rPr lang="en-US" dirty="0"/>
-              <a:t>Trivy scans both images for fixable high and critical vulnerabilities and fails the pipeline if it finds any. My first scan really failed: the backend had three high findings in Starlette, for example CVE-2025-62727, where crafted Range headers can cause denial of service, and the old nginx base image had forty-two high and critical findings in system libraries such as OpenSSL. I fixed them by upgrading FastAPI, which brings a patched Starlette, and moving to a current nginx image. Both scans now exit with zero. A clean scan means no fixable high or critical vulnerability exists in the image at scan time, which is why it runs on every build.</a:t>
+              <a:t>Trivy scans both images for fixable high and critical vulnerabilities and fails the pipeline if it finds any. My first scan failed: the backend had three high findings in Starlette, for example CVE-2025-62727, where crafted Range headers can cause denial of service, and the old nginx base image had forty-two high and critical findings in system libraries such as OpenSSL. I fixed them by upgrading FastAPI, which brings a patched Starlette, and moving to a current nginx image. Both scans now exit with zero. A clean scan means no fixable high or critical vulnerability exists in the image at scan time, which is why it runs on every build.</a:t>
             </a:r>
             <a:endParaRPr lang="en-US" dirty="0"/>
           </a:p>
@@ -7342,7 +7342,7 @@
                 <a:ea typeface="Cambria" pitchFamily="34" charset="-122"/>
                 <a:cs typeface="Cambria" pitchFamily="34" charset="-120"/>
               </a:rPr>
-              <a:t>18</a:t>
+              <a:t>22</a:t>
             </a:r>
             <a:endParaRPr lang="en-US" sz="4800" dirty="0"/>
           </a:p>
@@ -9240,7 +9240,7 @@
                   <a:schemeClr val="tx1"/>
                 </a:solidFill>
               </a:rPr>
-              <a:t>EKS cluster + managed node group, 2 x t3.medium</a:t>
+              <a:t>EKS cluster + managed node group, 2 x t3.small</a:t>
             </a:r>
             <a:endParaRPr lang="en-US" sz="1400" dirty="0"/>
           </a:p>

</xml_diff>

<commit_message>
Retake the git log screenshot and rebuild the deck with the final commit count
</commit_message>
<xml_diff>
--- a/docs/PlaceTrack-Capstone.pptx
+++ b/docs/PlaceTrack-Capstone.pptx
@@ -121,41 +121,41 @@
   <p:extLst>
     <p:ext uri="{521415D9-36F7-43E2-AB2F-B90AF26B5E84}">
       <p14:sectionLst xmlns:p14="http://schemas.microsoft.com/office/powerpoint/2010/main">
-        <p14:section name="Intro" id="{6dcb9cfe-6473-8e7e-e113-3129b9ed3246}">
+        <p14:section name="Intro" id="{44abc205-e53a-585a-a3f2-254096845d77}">
           <p14:sldIdLst>
             <p14:sldId id="256"/>
             <p14:sldId id="257"/>
           </p14:sldIdLst>
         </p14:section>
-        <p14:section name="App and tests" id="{18c4e3aa-2d90-5649-d56b-190b89da508d}">
+        <p14:section name="App and tests" id="{a68aaf5d-2263-0c85-1808-42d18d5137dd}">
           <p14:sldIdLst>
             <p14:sldId id="258"/>
             <p14:sldId id="259"/>
             <p14:sldId id="260"/>
           </p14:sldIdLst>
         </p14:section>
-        <p14:section name="Containers and CI" id="{b2aedb7a-3dc3-f912-7bd6-9c95c7ef4244}">
+        <p14:section name="Containers and CI" id="{f89c0f49-5fc4-1622-428b-beedd93d7bc6}">
           <p14:sldIdLst>
             <p14:sldId id="261"/>
             <p14:sldId id="262"/>
             <p14:sldId id="263"/>
           </p14:sldIdLst>
         </p14:section>
-        <p14:section name="Infrastructure" id="{66491778-d87d-0596-2bfe-c2ff575c4086}">
+        <p14:section name="Infrastructure" id="{3ab6aa8e-006b-7acc-9ab3-238ae512bda8}">
           <p14:sldIdLst>
             <p14:sldId id="264"/>
             <p14:sldId id="265"/>
             <p14:sldId id="266"/>
           </p14:sldIdLst>
         </p14:section>
-        <p14:section name="Operations" id="{bc01beed-2b0a-281b-9be4-6faf3745e9a3}">
+        <p14:section name="Operations" id="{9e244011-0170-d8a3-51a9-117f9e74ead4}">
           <p14:sldIdLst>
             <p14:sldId id="267"/>
             <p14:sldId id="268"/>
             <p14:sldId id="269"/>
           </p14:sldIdLst>
         </p14:section>
-        <p14:section name="Close" id="{da380b2e-fcf7-6d0f-963e-d5f2762a8c69}">
+        <p14:section name="Close" id="{54842158-c551-5dce-e0d7-90fc3767e22c}">
           <p14:sldIdLst>
             <p14:sldId id="270"/>
           </p14:sldIdLst>
@@ -7342,7 +7342,7 @@
                 <a:ea typeface="Cambria" pitchFamily="34" charset="-122"/>
                 <a:cs typeface="Cambria" pitchFamily="34" charset="-120"/>
               </a:rPr>
-              <a:t>22</a:t>
+              <a:t>23</a:t>
             </a:r>
             <a:endParaRPr lang="en-US" sz="4800" dirty="0"/>
           </a:p>
@@ -7469,7 +7469,7 @@
         <p:spPr>
           <a:xfrm>
             <a:off x="420624" y="2386584"/>
-            <a:ext cx="4670642" cy="2313432"/>
+            <a:ext cx="4633722" cy="2313432"/>
           </a:xfrm>
           <a:prstGeom prst="roundRect">
             <a:avLst>
@@ -7511,7 +7511,7 @@
         <p:spPr>
           <a:xfrm>
             <a:off x="457200" y="2423160"/>
-            <a:ext cx="4597490" cy="2240280"/>
+            <a:ext cx="4560570" cy="2240280"/>
           </a:xfrm>
           <a:prstGeom prst="rect">
             <a:avLst/>

</xml_diff>

<commit_message>
Simplify the project: drop the EBS driver and EKS-only storage class, shorten the README, keep one deck
</commit_message>
<xml_diff>
--- a/docs/PlaceTrack-Capstone.pptx
+++ b/docs/PlaceTrack-Capstone.pptx
@@ -121,41 +121,41 @@
   <p:extLst>
     <p:ext uri="{521415D9-36F7-43E2-AB2F-B90AF26B5E84}">
       <p14:sectionLst xmlns:p14="http://schemas.microsoft.com/office/powerpoint/2010/main">
-        <p14:section name="Intro" id="{44abc205-e53a-585a-a3f2-254096845d77}">
+        <p14:section name="Intro" id="{ad967065-6bb2-e6c9-4bef-86ce32fc01f1}">
           <p14:sldIdLst>
             <p14:sldId id="256"/>
             <p14:sldId id="257"/>
           </p14:sldIdLst>
         </p14:section>
-        <p14:section name="App and tests" id="{a68aaf5d-2263-0c85-1808-42d18d5137dd}">
+        <p14:section name="App and tests" id="{54be7cd1-0c11-d45d-89d2-6e720135c8b3}">
           <p14:sldIdLst>
             <p14:sldId id="258"/>
             <p14:sldId id="259"/>
             <p14:sldId id="260"/>
           </p14:sldIdLst>
         </p14:section>
-        <p14:section name="Containers and CI" id="{f89c0f49-5fc4-1622-428b-beedd93d7bc6}">
+        <p14:section name="Containers and CI" id="{22da194c-f544-87cf-7321-2a3e1c0e4ba1}">
           <p14:sldIdLst>
             <p14:sldId id="261"/>
             <p14:sldId id="262"/>
             <p14:sldId id="263"/>
           </p14:sldIdLst>
         </p14:section>
-        <p14:section name="Infrastructure" id="{3ab6aa8e-006b-7acc-9ab3-238ae512bda8}">
+        <p14:section name="Infrastructure" id="{28235b37-0a98-27ad-0099-67f0a6f9de83}">
           <p14:sldIdLst>
             <p14:sldId id="264"/>
             <p14:sldId id="265"/>
             <p14:sldId id="266"/>
           </p14:sldIdLst>
         </p14:section>
-        <p14:section name="Operations" id="{9e244011-0170-d8a3-51a9-117f9e74ead4}">
+        <p14:section name="Operations" id="{0244e4df-eb4a-4de5-1df2-74089d99b27a}">
           <p14:sldIdLst>
             <p14:sldId id="267"/>
             <p14:sldId id="268"/>
             <p14:sldId id="269"/>
           </p14:sldIdLst>
         </p14:section>
-        <p14:section name="Close" id="{54842158-c551-5dce-e0d7-90fc3767e22c}">
+        <p14:section name="Close" id="{107ffdaa-e589-95e4-b133-62671e3d15da}">
           <p14:sldIdLst>
             <p14:sldId id="270"/>
           </p14:sldIdLst>
@@ -740,7 +740,7 @@
           <a:p>
             <a:r>
               <a:rPr lang="en-US" dirty="0"/>
-              <a:t>This is the application loaded in a browser through the Kubernetes Ingress controller. The page comes from the frontend service, and its calls to slash api are routed by the same Ingress to the backend, which talks to Postgres. The chart is the same for minikube and for EKS.</a:t>
+              <a:t>This is the application loaded in a browser through the Kubernetes Ingress controller. The page comes from the frontend service, and its calls to slash api are routed by the same Ingress to the backend, which talks to Postgres.</a:t>
             </a:r>
             <a:endParaRPr lang="en-US" dirty="0"/>
           </a:p>
@@ -1796,7 +1796,7 @@
           <a:p>
             <a:r>
               <a:rPr lang="en-US" dirty="0"/>
-              <a:t>Terraform builds a VPC with two public subnets in two availability zones and an EKS cluster with a managed node group of two nodes. I restricted the cluster API to my own IP address, and gave the EBS storage driver its own narrowly scoped role instead of attaching a policy to every node. The plan shows fifty-three resources to add and nothing to change or destroy. Applying creates billable resources, so the apply, the console screenshots and the destroy are the remaining evidence for this module.</a:t>
+              <a:t>Terraform builds a VPC with two public subnets in two availability zones and an EKS cluster with a managed node group of two nodes. I limited the cluster API to my own IP address. The first plan showed fifty-three resources to add and nothing to change or destroy. Applying creates billable resources, so the apply, the console screenshots and the destroy are the remaining evidence for this module.</a:t>
             </a:r>
             <a:endParaRPr lang="en-US" dirty="0"/>
           </a:p>
@@ -3140,7 +3140,7 @@
                   <a:schemeClr val="tx1"/>
                 </a:solidFill>
               </a:rPr>
-              <a:t>Same chart for minikube and EKS (EKS adds a gp3 StorageClass)</a:t>
+              <a:t>Deployed with one helm command</a:t>
             </a:r>
             <a:endParaRPr lang="en-US" sz="1400" dirty="0"/>
           </a:p>
@@ -7342,7 +7342,7 @@
                 <a:ea typeface="Cambria" pitchFamily="34" charset="-122"/>
                 <a:cs typeface="Cambria" pitchFamily="34" charset="-120"/>
               </a:rPr>
-              <a:t>23</a:t>
+              <a:t>24</a:t>
             </a:r>
             <a:endParaRPr lang="en-US" sz="4800" dirty="0"/>
           </a:p>
@@ -7469,7 +7469,7 @@
         <p:spPr>
           <a:xfrm>
             <a:off x="420624" y="2386584"/>
-            <a:ext cx="4633722" cy="2313432"/>
+            <a:ext cx="4659761" cy="2313432"/>
           </a:xfrm>
           <a:prstGeom prst="roundRect">
             <a:avLst>
@@ -7511,7 +7511,7 @@
         <p:spPr>
           <a:xfrm>
             <a:off x="457200" y="2423160"/>
-            <a:ext cx="4560570" cy="2240280"/>
+            <a:ext cx="4586609" cy="2240280"/>
           </a:xfrm>
           <a:prstGeom prst="rect">
             <a:avLst/>
@@ -9258,25 +9258,7 @@
                   <a:schemeClr val="tx1"/>
                 </a:solidFill>
               </a:rPr>
-              <a:t>EBS CSI driver with its own IRSA role</a:t>
-            </a:r>
-            <a:endParaRPr lang="en-US" sz="1400" dirty="0"/>
-          </a:p>
-          <a:p>
-            <a:pPr marL="342900" indent="-342900">
-              <a:spcAft>
-                <a:spcPts val="800"/>
-              </a:spcAft>
-              <a:buSzPct val="100000"/>
-              <a:buChar char="•"/>
-            </a:pPr>
-            <a:r>
-              <a:rPr lang="en-US" sz="1400" dirty="0">
-                <a:solidFill>
-                  <a:schemeClr val="tx1"/>
-                </a:solidFill>
-              </a:rPr>
-              <a:t>API endpoint restricted to my IP; no secrets in code</a:t>
+              <a:t>API endpoint limited to my IP; no secrets in code</a:t>
             </a:r>
             <a:endParaRPr lang="en-US" sz="1400" dirty="0"/>
           </a:p>

</xml_diff>

<commit_message>
Add the terraform destroy result and update the deck with the AWS evidence
</commit_message>
<xml_diff>
--- a/docs/PlaceTrack-Capstone.pptx
+++ b/docs/PlaceTrack-Capstone.pptx
@@ -20,9 +20,10 @@
     <p:sldId id="268" r:id="rId14"/>
     <p:sldId id="269" r:id="rId15"/>
     <p:sldId id="270" r:id="rId16"/>
+    <p:sldId id="271" r:id="rId17"/>
   </p:sldIdLst>
   <p:notesMasterIdLst>
-    <p:notesMasterId r:id="rId17"/>
+    <p:notesMasterId r:id="rId18"/>
   </p:notesMasterIdLst>
   <p:sldSz cx="9144000" cy="5143500"/>
   <p:notesSz cx="5143500" cy="9144000"/>
@@ -121,43 +122,44 @@
   <p:extLst>
     <p:ext uri="{521415D9-36F7-43E2-AB2F-B90AF26B5E84}">
       <p14:sectionLst xmlns:p14="http://schemas.microsoft.com/office/powerpoint/2010/main">
-        <p14:section name="Intro" id="{ad967065-6bb2-e6c9-4bef-86ce32fc01f1}">
+        <p14:section name="Intro" id="{53a977af-a372-00ed-a7b8-ae4abab7f58b}">
           <p14:sldIdLst>
             <p14:sldId id="256"/>
             <p14:sldId id="257"/>
           </p14:sldIdLst>
         </p14:section>
-        <p14:section name="App and tests" id="{54be7cd1-0c11-d45d-89d2-6e720135c8b3}">
+        <p14:section name="App and tests" id="{13e714e7-7366-c560-61ff-c3f4f8faaa0f}">
           <p14:sldIdLst>
             <p14:sldId id="258"/>
             <p14:sldId id="259"/>
             <p14:sldId id="260"/>
           </p14:sldIdLst>
         </p14:section>
-        <p14:section name="Containers and CI" id="{22da194c-f544-87cf-7321-2a3e1c0e4ba1}">
+        <p14:section name="Containers and CI" id="{43e57819-cd90-b1b6-96bc-5838ce9c01b7}">
           <p14:sldIdLst>
             <p14:sldId id="261"/>
             <p14:sldId id="262"/>
             <p14:sldId id="263"/>
           </p14:sldIdLst>
         </p14:section>
-        <p14:section name="Infrastructure" id="{28235b37-0a98-27ad-0099-67f0a6f9de83}">
+        <p14:section name="Infrastructure" id="{0111f913-7920-e40a-971f-ac2b844aff6e}">
           <p14:sldIdLst>
             <p14:sldId id="264"/>
             <p14:sldId id="265"/>
             <p14:sldId id="266"/>
+            <p14:sldId id="267"/>
           </p14:sldIdLst>
         </p14:section>
-        <p14:section name="Operations" id="{0244e4df-eb4a-4de5-1df2-74089d99b27a}">
+        <p14:section name="Operations" id="{48b086d2-d5a3-208e-f5f3-f28d39d5e972}">
           <p14:sldIdLst>
-            <p14:sldId id="267"/>
             <p14:sldId id="268"/>
             <p14:sldId id="269"/>
+            <p14:sldId id="270"/>
           </p14:sldIdLst>
         </p14:section>
-        <p14:section name="Close" id="{107ffdaa-e589-95e4-b133-62671e3d15da}">
+        <p14:section name="Close" id="{3546357d-a158-75cd-2597-0aa50fe30d97}">
           <p14:sldIdLst>
-            <p14:sldId id="270"/>
+            <p14:sldId id="271"/>
           </p14:sldIdLst>
         </p14:section>
       </p14:sectionLst>
@@ -652,7 +654,7 @@
           <a:p>
             <a:r>
               <a:rPr lang="en-US" dirty="0"/>
-              <a:t>A single Helm chart deploys everything into the placetrack namespace: two replicas each of the backend and frontend, a Postgres StatefulSet, ClusterIP services, an Ingress that sends slash to the frontend and slash api to the backend, and a horizontal pod autoscaler. A Helm hook job runs the database migration after install. All pods are running with zero restarts.</a:t>
+              <a:t>The console shows the VPC with its two public subnets and the EKS cluster as Active with one node group. kubectl showed both nodes Ready. After taking the screenshots I ran terraform destroy. It removed everything, and a check afterwards showed no cluster, VPC or instances left, so there is no billing.</a:t>
             </a:r>
             <a:endParaRPr lang="en-US" dirty="0"/>
           </a:p>
@@ -740,7 +742,7 @@
           <a:p>
             <a:r>
               <a:rPr lang="en-US" dirty="0"/>
-              <a:t>This is the application loaded in a browser through the Kubernetes Ingress controller. The page comes from the frontend service, and its calls to slash api are routed by the same Ingress to the backend, which talks to Postgres.</a:t>
+              <a:t>A single Helm chart deploys everything into the placetrack namespace: two replicas each of the backend and frontend, a Postgres StatefulSet, ClusterIP services, an Ingress that sends slash to the frontend and slash api to the backend, and a horizontal pod autoscaler. A Helm hook job runs the database migration after install. All pods are running with zero restarts.</a:t>
             </a:r>
             <a:endParaRPr lang="en-US" dirty="0"/>
           </a:p>
@@ -828,7 +830,7 @@
           <a:p>
             <a:r>
               <a:rPr lang="en-US" dirty="0"/>
-              <a:t>The backend exposes Prometheus metrics. A ServiceMonitor tells Prometheus to scrape both backend pods, and the targets page shows both up. The Grafana dashboard I built shows request rate per endpoint, the ninety-fifth percentile latency, error responses and the number of healthy backend pods. These panels have live data from a load test, not mock data.</a:t>
+              <a:t>This is the application loaded in a browser through the Kubernetes Ingress controller. The page comes from the frontend service, and its calls to slash api are routed by the same Ingress to the backend, which talks to Postgres.</a:t>
             </a:r>
             <a:endParaRPr lang="en-US" dirty="0"/>
           </a:p>
@@ -916,7 +918,7 @@
           <a:p>
             <a:r>
               <a:rPr lang="en-US" dirty="0"/>
-              <a:t>I broke the cluster in two ways and fixed both. First, a deployment with an image tag that does not exist ends in ErrImagePull and ImagePullBackOff; describe pod showed the pull failure and the fix was a valid tag. Second, a service whose selector had a typo: the pod was Running but the service had no endpoints, so nothing was reachable. Comparing the selector with the pod labels revealed it. The full five-step write-ups are in the troubleshooting folder.</a:t>
+              <a:t>The backend exposes Prometheus metrics. A ServiceMonitor tells Prometheus to scrape both backend pods, and the targets page shows both up. The Grafana dashboard I built shows request rate per endpoint, the ninety-fifth percentile latency, error responses and the number of healthy backend pods. These panels have live data from a load test, not mock data.</a:t>
             </a:r>
             <a:endParaRPr lang="en-US" dirty="0"/>
           </a:p>
@@ -1004,7 +1006,7 @@
           <a:p>
             <a:r>
               <a:rPr lang="en-US" dirty="0"/>
-              <a:t>For the live demo I change a visible string in the React app, commit and push. GitHub Actions runs the tests, builds, scans and pushes the images tagged with the new commit. Then I run the deploy script with that SHA, Helm rolls out the new pods, and refreshing the browser shows the change.</a:t>
+              <a:t>I broke the cluster in two ways and fixed both. First, a deployment with an image tag that does not exist ends in ErrImagePull and ImagePullBackOff; describe pod showed the pull failure and the fix was a valid tag. Second, a service whose selector had a typo: the pod was Running but the service had no endpoints, so nothing was reachable. Comparing the selector with the pod labels revealed it. The full five-step write-ups are in the troubleshooting folder.</a:t>
             </a:r>
             <a:endParaRPr lang="en-US" dirty="0"/>
           </a:p>
@@ -1092,7 +1094,7 @@
           <a:p>
             <a:r>
               <a:rPr lang="en-US" dirty="0"/>
-              <a:t>Four things I will remember. A passing build is not a secure build: Trivy failed my first images and I had to fix real vulnerabilities. nginx resolves upstream names once at startup, which caused a crash loop until I used a runtime resolver, and a request through the frontend service then showed that the resolver ignores search domains, so I switched to the full service DNS name and the 502 became a 200. Running does not mean ready, and ready does not mean reachable. And secrets are generated at deploy time, never committed. Thank you.</a:t>
+              <a:t>For the live demo I change a visible string in the React app, commit and push. GitHub Actions runs the tests, builds, scans and pushes the images tagged with the new commit. Then I run the deploy script with that SHA, Helm rolls out the new pods, and refreshing the browser shows the change.</a:t>
             </a:r>
             <a:endParaRPr lang="en-US" dirty="0"/>
           </a:p>
@@ -1116,6 +1118,94 @@
             <a:fld id="{F7021451-1387-4CA6-816F-3879F97B5CBC}" type="slidenum">
               <a:rPr lang="en-US"/>
               <a:t>15</a:t>
+            </a:fld>
+            <a:endParaRPr lang="en-US"/>
+          </a:p>
+        </p:txBody>
+      </p:sp>
+    </p:spTree>
+    <p:extLst>
+      <p:ext uri="{BB962C8B-B14F-4D97-AF65-F5344CB8AC3E}">
+        <p14:creationId xmlns:p14="http://schemas.microsoft.com/office/powerpoint/2010/main" val="1024086991"/>
+      </p:ext>
+    </p:extLst>
+  </p:cSld>
+  <p:clrMapOvr>
+    <a:masterClrMapping/>
+  </p:clrMapOvr>
+</p:notes>
+</file>
+
+<file path=ppt/notesSlides/notesSlide16.xml><?xml version="1.0" encoding="utf-8"?>
+<p:notes xmlns:a="http://schemas.openxmlformats.org/drawingml/2006/main" xmlns:r="http://schemas.openxmlformats.org/officeDocument/2006/relationships" xmlns:p="http://schemas.openxmlformats.org/presentationml/2006/main">
+  <p:cSld>
+    <p:spTree>
+      <p:nvGrpSpPr>
+        <p:cNvPr id="1" name=""/>
+        <p:cNvGrpSpPr/>
+        <p:nvPr/>
+      </p:nvGrpSpPr>
+      <p:grpSpPr>
+        <a:xfrm>
+          <a:off x="0" y="0"/>
+          <a:ext cx="0" cy="0"/>
+          <a:chOff x="0" y="0"/>
+          <a:chExt cx="0" cy="0"/>
+        </a:xfrm>
+      </p:grpSpPr>
+      <p:sp>
+        <p:nvSpPr>
+          <p:cNvPr id="2" name="Slide Image Placeholder 1"/>
+          <p:cNvSpPr>
+            <a:spLocks noGrp="1" noRot="1" noChangeAspect="1"/>
+          </p:cNvSpPr>
+          <p:nvPr>
+            <p:ph type="sldImg"/>
+          </p:nvPr>
+        </p:nvSpPr>
+        <p:spPr/>
+      </p:sp>
+      <p:sp>
+        <p:nvSpPr>
+          <p:cNvPr id="3" name="Notes Placeholder 2"/>
+          <p:cNvSpPr>
+            <a:spLocks noGrp="1"/>
+          </p:cNvSpPr>
+          <p:nvPr>
+            <p:ph type="body" idx="1"/>
+          </p:nvPr>
+        </p:nvSpPr>
+        <p:spPr/>
+        <p:txBody>
+          <a:bodyPr/>
+          <a:lstStyle/>
+          <a:p>
+            <a:r>
+              <a:rPr lang="en-US" dirty="0"/>
+              <a:t>Four things I will remember. A passing build is not a secure build: Trivy failed my first images and I had to fix real vulnerabilities. nginx resolves upstream names once at startup, which caused a crash loop until I used a runtime resolver, and a request through the frontend service then showed that the resolver ignores search domains, so I switched to the full service DNS name and the 502 became a 200. Running does not mean ready, and ready does not mean reachable. And secrets are generated at deploy time, never committed. Thank you.</a:t>
+            </a:r>
+            <a:endParaRPr lang="en-US" dirty="0"/>
+          </a:p>
+        </p:txBody>
+      </p:sp>
+      <p:sp>
+        <p:nvSpPr>
+          <p:cNvPr id="4" name="Slide Number Placeholder 3"/>
+          <p:cNvSpPr>
+            <a:spLocks noGrp="1"/>
+          </p:cNvSpPr>
+          <p:nvPr>
+            <p:ph type="sldNum" sz="quarter" idx="10"/>
+          </p:nvPr>
+        </p:nvSpPr>
+        <p:spPr/>
+        <p:txBody>
+          <a:bodyPr/>
+          <a:lstStyle/>
+          <a:p>
+            <a:fld id="{F7021451-1387-4CA6-816F-3879F97B5CBC}" type="slidenum">
+              <a:rPr lang="en-US"/>
+              <a:t>16</a:t>
             </a:fld>
             <a:endParaRPr lang="en-US"/>
           </a:p>
@@ -1796,7 +1886,7 @@
           <a:p>
             <a:r>
               <a:rPr lang="en-US" dirty="0"/>
-              <a:t>Terraform builds a VPC with two public subnets in two availability zones and an EKS cluster with a managed node group of two nodes. I limited the cluster API to my own IP address. The first plan showed fifty-three resources to add and nothing to change or destroy. Applying creates billable resources, so the apply, the console screenshots and the destroy are the remaining evidence for this module.</a:t>
+              <a:t>Terraform builds a VPC with two public subnets in two availability zones and an EKS cluster with a managed node group. I limited the cluster API to my own IP address. The first plan showed fifty-three resources to add. The first apply created the VPC and the cluster, but the node group failed, because this account's free plan does not allow t3.medium. I switched to t3.small, applied again, and the apply completed.</a:t>
             </a:r>
             <a:endParaRPr lang="en-US" dirty="0"/>
           </a:p>
@@ -2666,7 +2756,7 @@
                   <a:schemeClr val="tx1"/>
                 </a:solidFill>
               </a:rPr>
-              <a:t>Kubernetes and Helm</a:t>
+              <a:t>AWS Console</a:t>
             </a:r>
             <a:endParaRPr lang="en-US" sz="3200" dirty="0"/>
           </a:p>
@@ -2724,7 +2814,7 @@
                   <a:schemeClr val="bg1"/>
                 </a:solidFill>
               </a:rPr>
-              <a:t>M8</a:t>
+              <a:t>M7</a:t>
             </a:r>
             <a:endParaRPr lang="en-US" sz="1400" dirty="0"/>
           </a:p>
@@ -2732,18 +2822,18 @@
       </p:sp>
       <p:sp>
         <p:nvSpPr>
-          <p:cNvPr id="5" name="kubectl get pods frame"/>
+          <p:cNvPr id="5" name="AWS Console: VPC with two public subnets frame"/>
           <p:cNvSpPr/>
           <p:nvPr/>
         </p:nvSpPr>
         <p:spPr>
           <a:xfrm>
             <a:off x="420624" y="1060704"/>
-            <a:ext cx="7349830" cy="1764792"/>
+            <a:ext cx="4050792" cy="2471401"/>
           </a:xfrm>
           <a:prstGeom prst="roundRect">
             <a:avLst>
-              <a:gd name="adj" fmla="val 2591"/>
+              <a:gd name="adj" fmla="val 1850"/>
             </a:avLst>
           </a:prstGeom>
           <a:solidFill>
@@ -2766,7 +2856,7 @@
       </p:sp>
       <p:pic>
         <p:nvPicPr>
-          <p:cNvPr id="6" name="Image 0" descr="kubectl get pods">    </p:cNvPr>
+          <p:cNvPr id="6" name="Image 0" descr="AWS Console: VPC with two public subnets">    </p:cNvPr>
           <p:cNvPicPr>
             <a:picLocks noChangeAspect="1"/>
           </p:cNvPicPr>
@@ -2781,7 +2871,7 @@
         <p:spPr>
           <a:xfrm>
             <a:off x="457200" y="1097280"/>
-            <a:ext cx="7276678" cy="1691640"/>
+            <a:ext cx="3977640" cy="2398249"/>
           </a:xfrm>
           <a:prstGeom prst="rect">
             <a:avLst/>
@@ -2790,18 +2880,18 @@
       </p:pic>
       <p:sp>
         <p:nvSpPr>
-          <p:cNvPr id="7" name="kubectl get svc, ingress, hpa frame"/>
+          <p:cNvPr id="7" name="AWS Console: EKS cluster frame"/>
           <p:cNvSpPr/>
           <p:nvPr/>
         </p:nvSpPr>
         <p:spPr>
           <a:xfrm>
-            <a:off x="420624" y="2889504"/>
-            <a:ext cx="6272719" cy="1810512"/>
+            <a:off x="4672584" y="1060704"/>
+            <a:ext cx="4050792" cy="2471401"/>
           </a:xfrm>
           <a:prstGeom prst="roundRect">
             <a:avLst>
-              <a:gd name="adj" fmla="val 2525"/>
+              <a:gd name="adj" fmla="val 1850"/>
             </a:avLst>
           </a:prstGeom>
           <a:solidFill>
@@ -2824,7 +2914,7 @@
       </p:sp>
       <p:pic>
         <p:nvPicPr>
-          <p:cNvPr id="8" name="Image 1" descr="kubectl get svc, ingress, hpa">    </p:cNvPr>
+          <p:cNvPr id="8" name="Image 1" descr="AWS Console: EKS cluster">    </p:cNvPr>
           <p:cNvPicPr>
             <a:picLocks noChangeAspect="1"/>
           </p:cNvPicPr>
@@ -2838,14 +2928,90 @@
         </p:blipFill>
         <p:spPr>
           <a:xfrm>
-            <a:off x="457200" y="2926080"/>
-            <a:ext cx="6199567" cy="1737360"/>
+            <a:off x="4709160" y="1097280"/>
+            <a:ext cx="3977640" cy="2398249"/>
           </a:xfrm>
           <a:prstGeom prst="rect">
             <a:avLst/>
           </a:prstGeom>
         </p:spPr>
       </p:pic>
+      <p:sp>
+        <p:nvSpPr>
+          <p:cNvPr id="9" name="Text 5"/>
+          <p:cNvSpPr txBox="1"/>
+          <p:nvPr/>
+        </p:nvSpPr>
+        <p:spPr>
+          <a:xfrm>
+            <a:off x="457200" y="3703320"/>
+            <a:ext cx="8229600" cy="1005840"/>
+          </a:xfrm>
+          <a:prstGeom prst="rect">
+            <a:avLst/>
+          </a:prstGeom>
+          <a:noFill/>
+          <a:ln/>
+        </p:spPr>
+        <p:txBody>
+          <a:bodyPr wrap="square" lIns="0" tIns="0" rIns="0" bIns="0" rtlCol="0" anchor="t"/>
+          <a:lstStyle/>
+          <a:p>
+            <a:pPr marL="342900" indent="-342900">
+              <a:spcAft>
+                <a:spcPts val="800"/>
+              </a:spcAft>
+              <a:buSzPct val="100000"/>
+              <a:buChar char="•"/>
+            </a:pPr>
+            <a:r>
+              <a:rPr lang="en-US" sz="1300" dirty="0">
+                <a:solidFill>
+                  <a:schemeClr val="tx1"/>
+                </a:solidFill>
+              </a:rPr>
+              <a:t>VPC placetrack-vpc with subnets in ap-south-1a and ap-south-1b</a:t>
+            </a:r>
+            <a:endParaRPr lang="en-US" sz="1300" dirty="0"/>
+          </a:p>
+          <a:p>
+            <a:pPr marL="342900" indent="-342900">
+              <a:spcAft>
+                <a:spcPts val="800"/>
+              </a:spcAft>
+              <a:buSzPct val="100000"/>
+              <a:buChar char="•"/>
+            </a:pPr>
+            <a:r>
+              <a:rPr lang="en-US" sz="1300" dirty="0">
+                <a:solidFill>
+                  <a:schemeClr val="tx1"/>
+                </a:solidFill>
+              </a:rPr>
+              <a:t>EKS cluster Active, 1 node group, 2 nodes Ready</a:t>
+            </a:r>
+            <a:endParaRPr lang="en-US" sz="1300" dirty="0"/>
+          </a:p>
+          <a:p>
+            <a:pPr marL="342900" indent="-342900">
+              <a:spcAft>
+                <a:spcPts val="800"/>
+              </a:spcAft>
+              <a:buSzPct val="100000"/>
+              <a:buChar char="•"/>
+            </a:pPr>
+            <a:r>
+              <a:rPr lang="en-US" sz="1300" dirty="0">
+                <a:solidFill>
+                  <a:schemeClr val="tx1"/>
+                </a:solidFill>
+              </a:rPr>
+              <a:t>terraform destroy removed everything, so nothing is left to bill</a:t>
+            </a:r>
+            <a:endParaRPr lang="en-US" sz="1300" dirty="0"/>
+          </a:p>
+        </p:txBody>
+      </p:sp>
       <p:sp>
         <p:nvSpPr>
           <p:cNvPr id="25" name="Slide Number Placeholder 0"/>
@@ -2948,7 +3114,7 @@
                   <a:schemeClr val="tx1"/>
                 </a:solidFill>
               </a:rPr>
-              <a:t>Through the Ingress</a:t>
+              <a:t>Kubernetes and Helm</a:t>
             </a:r>
             <a:endParaRPr lang="en-US" sz="3200" dirty="0"/>
           </a:p>
@@ -3014,18 +3180,18 @@
       </p:sp>
       <p:sp>
         <p:nvSpPr>
-          <p:cNvPr id="5" name="PlaceTrack served through the Ingress frame"/>
+          <p:cNvPr id="5" name="kubectl get pods frame"/>
           <p:cNvSpPr/>
           <p:nvPr/>
         </p:nvSpPr>
         <p:spPr>
           <a:xfrm>
             <a:off x="420624" y="1060704"/>
-            <a:ext cx="5468112" cy="3445002"/>
+            <a:ext cx="7349830" cy="1764792"/>
           </a:xfrm>
           <a:prstGeom prst="roundRect">
             <a:avLst>
-              <a:gd name="adj" fmla="val 1327"/>
+              <a:gd name="adj" fmla="val 2591"/>
             </a:avLst>
           </a:prstGeom>
           <a:solidFill>
@@ -3048,7 +3214,7 @@
       </p:sp>
       <p:pic>
         <p:nvPicPr>
-          <p:cNvPr id="6" name="Image 0" descr="PlaceTrack served through the Ingress">    </p:cNvPr>
+          <p:cNvPr id="6" name="Image 0" descr="kubectl get pods">    </p:cNvPr>
           <p:cNvPicPr>
             <a:picLocks noChangeAspect="1"/>
           </p:cNvPicPr>
@@ -3063,7 +3229,7 @@
         <p:spPr>
           <a:xfrm>
             <a:off x="457200" y="1097280"/>
-            <a:ext cx="5394960" cy="3371850"/>
+            <a:ext cx="7276678" cy="1691640"/>
           </a:xfrm>
           <a:prstGeom prst="rect">
             <a:avLst/>
@@ -3072,80 +3238,62 @@
       </p:pic>
       <p:sp>
         <p:nvSpPr>
-          <p:cNvPr id="7" name="Text 4"/>
-          <p:cNvSpPr txBox="1"/>
-          <p:nvPr/>
-        </p:nvSpPr>
-        <p:spPr>
-          <a:xfrm>
-            <a:off x="6126480" y="1188720"/>
-            <a:ext cx="2560320" cy="3108960"/>
-          </a:xfrm>
-          <a:prstGeom prst="rect">
-            <a:avLst/>
-          </a:prstGeom>
-          <a:noFill/>
-          <a:ln/>
-        </p:spPr>
-        <p:txBody>
-          <a:bodyPr wrap="square" lIns="0" tIns="0" rIns="0" bIns="0" rtlCol="0" anchor="t"/>
-          <a:lstStyle/>
-          <a:p>
-            <a:pPr marL="342900" indent="-342900">
-              <a:spcAft>
-                <a:spcPts val="800"/>
-              </a:spcAft>
-              <a:buSzPct val="100000"/>
-              <a:buChar char="•"/>
-            </a:pPr>
-            <a:r>
-              <a:rPr lang="en-US" sz="1400" dirty="0">
-                <a:solidFill>
-                  <a:schemeClr val="tx1"/>
-                </a:solidFill>
-              </a:rPr>
-              <a:t>Ingress sends / to the frontend and /api to the backend, which uses Postgres</a:t>
-            </a:r>
-            <a:endParaRPr lang="en-US" sz="1400" dirty="0"/>
-          </a:p>
-          <a:p>
-            <a:pPr marL="342900" indent="-342900">
-              <a:spcAft>
-                <a:spcPts val="800"/>
-              </a:spcAft>
-              <a:buSzPct val="100000"/>
-              <a:buChar char="•"/>
-            </a:pPr>
-            <a:r>
-              <a:rPr lang="en-US" sz="1400" dirty="0">
-                <a:solidFill>
-                  <a:schemeClr val="tx1"/>
-                </a:solidFill>
-              </a:rPr>
-              <a:t>Live data written through /api</a:t>
-            </a:r>
-            <a:endParaRPr lang="en-US" sz="1400" dirty="0"/>
-          </a:p>
-          <a:p>
-            <a:pPr marL="342900" indent="-342900">
-              <a:spcAft>
-                <a:spcPts val="800"/>
-              </a:spcAft>
-              <a:buSzPct val="100000"/>
-              <a:buChar char="•"/>
-            </a:pPr>
-            <a:r>
-              <a:rPr lang="en-US" sz="1400" dirty="0">
-                <a:solidFill>
-                  <a:schemeClr val="tx1"/>
-                </a:solidFill>
-              </a:rPr>
-              <a:t>Deployed with one helm command</a:t>
-            </a:r>
-            <a:endParaRPr lang="en-US" sz="1400" dirty="0"/>
-          </a:p>
-        </p:txBody>
-      </p:sp>
+          <p:cNvPr id="7" name="kubectl get svc, ingress, hpa frame"/>
+          <p:cNvSpPr/>
+          <p:nvPr/>
+        </p:nvSpPr>
+        <p:spPr>
+          <a:xfrm>
+            <a:off x="420624" y="2889504"/>
+            <a:ext cx="6272719" cy="1810512"/>
+          </a:xfrm>
+          <a:prstGeom prst="roundRect">
+            <a:avLst>
+              <a:gd name="adj" fmla="val 2525"/>
+            </a:avLst>
+          </a:prstGeom>
+          <a:solidFill>
+            <a:schemeClr val="bg1"/>
+          </a:solidFill>
+          <a:ln w="9525">
+            <a:solidFill>
+              <a:schemeClr val="accent6"/>
+            </a:solidFill>
+            <a:prstDash val="solid"/>
+          </a:ln>
+          <a:effectLst>
+            <a:outerShdw sx="100000" sy="100000" kx="0" ky="0" algn="bl" rotWithShape="0" blurRad="76200" dist="25400" dir="5400000">
+              <a:srgbClr val="000000">
+                <a:alpha val="18000"/>
+              </a:srgbClr>
+            </a:outerShdw>
+          </a:effectLst>
+        </p:spPr>
+      </p:sp>
+      <p:pic>
+        <p:nvPicPr>
+          <p:cNvPr id="8" name="Image 1" descr="kubectl get svc, ingress, hpa">    </p:cNvPr>
+          <p:cNvPicPr>
+            <a:picLocks noChangeAspect="1"/>
+          </p:cNvPicPr>
+          <p:nvPr/>
+        </p:nvPicPr>
+        <p:blipFill>
+          <a:blip r:embed="rId2"/>
+          <a:stretch>
+            <a:fillRect/>
+          </a:stretch>
+        </p:blipFill>
+        <p:spPr>
+          <a:xfrm>
+            <a:off x="457200" y="2926080"/>
+            <a:ext cx="6199567" cy="1737360"/>
+          </a:xfrm>
+          <a:prstGeom prst="rect">
+            <a:avLst/>
+          </a:prstGeom>
+        </p:spPr>
+      </p:pic>
       <p:sp>
         <p:nvSpPr>
           <p:cNvPr id="25" name="Slide Number Placeholder 0"/>
@@ -3248,7 +3396,7 @@
                   <a:schemeClr val="tx1"/>
                 </a:solidFill>
               </a:rPr>
-              <a:t>Observability</a:t>
+              <a:t>Through the Ingress</a:t>
             </a:r>
             <a:endParaRPr lang="en-US" sz="3200" dirty="0"/>
           </a:p>
@@ -3306,7 +3454,7 @@
                   <a:schemeClr val="bg1"/>
                 </a:solidFill>
               </a:rPr>
-              <a:t>M9</a:t>
+              <a:t>M8</a:t>
             </a:r>
             <a:endParaRPr lang="en-US" sz="1400" dirty="0"/>
           </a:p>
@@ -3314,18 +3462,18 @@
       </p:sp>
       <p:sp>
         <p:nvSpPr>
-          <p:cNvPr id="5" name="Prometheus targets, both backend pods UP frame"/>
+          <p:cNvPr id="5" name="PlaceTrack served through the Ingress frame"/>
           <p:cNvSpPr/>
           <p:nvPr/>
         </p:nvSpPr>
         <p:spPr>
           <a:xfrm>
             <a:off x="420624" y="1060704"/>
-            <a:ext cx="4050792" cy="2559177"/>
+            <a:ext cx="5468112" cy="3445002"/>
           </a:xfrm>
           <a:prstGeom prst="roundRect">
             <a:avLst>
-              <a:gd name="adj" fmla="val 1787"/>
+              <a:gd name="adj" fmla="val 1327"/>
             </a:avLst>
           </a:prstGeom>
           <a:solidFill>
@@ -3348,7 +3496,7 @@
       </p:sp>
       <p:pic>
         <p:nvPicPr>
-          <p:cNvPr id="6" name="Image 0" descr="Prometheus targets, both backend pods UP">    </p:cNvPr>
+          <p:cNvPr id="6" name="Image 0" descr="PlaceTrack served through the Ingress">    </p:cNvPr>
           <p:cNvPicPr>
             <a:picLocks noChangeAspect="1"/>
           </p:cNvPicPr>
@@ -3363,7 +3511,7 @@
         <p:spPr>
           <a:xfrm>
             <a:off x="457200" y="1097280"/>
-            <a:ext cx="3977640" cy="2486025"/>
+            <a:ext cx="5394960" cy="3371850"/>
           </a:xfrm>
           <a:prstGeom prst="rect">
             <a:avLst/>
@@ -3372,72 +3520,14 @@
       </p:pic>
       <p:sp>
         <p:nvSpPr>
-          <p:cNvPr id="7" name="Grafana dashboard with live panels frame"/>
-          <p:cNvSpPr/>
-          <p:nvPr/>
-        </p:nvSpPr>
-        <p:spPr>
-          <a:xfrm>
-            <a:off x="4672584" y="1060704"/>
-            <a:ext cx="4050792" cy="2559177"/>
-          </a:xfrm>
-          <a:prstGeom prst="roundRect">
-            <a:avLst>
-              <a:gd name="adj" fmla="val 1787"/>
-            </a:avLst>
-          </a:prstGeom>
-          <a:solidFill>
-            <a:schemeClr val="bg1"/>
-          </a:solidFill>
-          <a:ln w="9525">
-            <a:solidFill>
-              <a:schemeClr val="accent6"/>
-            </a:solidFill>
-            <a:prstDash val="solid"/>
-          </a:ln>
-          <a:effectLst>
-            <a:outerShdw sx="100000" sy="100000" kx="0" ky="0" algn="bl" rotWithShape="0" blurRad="76200" dist="25400" dir="5400000">
-              <a:srgbClr val="000000">
-                <a:alpha val="18000"/>
-              </a:srgbClr>
-            </a:outerShdw>
-          </a:effectLst>
-        </p:spPr>
-      </p:sp>
-      <p:pic>
-        <p:nvPicPr>
-          <p:cNvPr id="8" name="Image 1" descr="Grafana dashboard with live panels">    </p:cNvPr>
-          <p:cNvPicPr>
-            <a:picLocks noChangeAspect="1"/>
-          </p:cNvPicPr>
-          <p:nvPr/>
-        </p:nvPicPr>
-        <p:blipFill>
-          <a:blip r:embed="rId2"/>
-          <a:stretch>
-            <a:fillRect/>
-          </a:stretch>
-        </p:blipFill>
-        <p:spPr>
-          <a:xfrm>
-            <a:off x="4709160" y="1097280"/>
-            <a:ext cx="3977640" cy="2486025"/>
-          </a:xfrm>
-          <a:prstGeom prst="rect">
-            <a:avLst/>
-          </a:prstGeom>
-        </p:spPr>
-      </p:pic>
-      <p:sp>
-        <p:nvSpPr>
-          <p:cNvPr id="9" name="Text 5"/>
+          <p:cNvPr id="7" name="Text 4"/>
           <p:cNvSpPr txBox="1"/>
           <p:nvPr/>
         </p:nvSpPr>
         <p:spPr>
           <a:xfrm>
-            <a:off x="457200" y="3794760"/>
-            <a:ext cx="8229600" cy="914400"/>
+            <a:off x="6126480" y="1188720"/>
+            <a:ext cx="2560320" cy="3108960"/>
           </a:xfrm>
           <a:prstGeom prst="rect">
             <a:avLst/>
@@ -3462,7 +3552,7 @@
                   <a:schemeClr val="tx1"/>
                 </a:solidFill>
               </a:rPr>
-              <a:t>/metrics exposed by FastAPI; ServiceMonitor makes Prometheus scrape both pods</a:t>
+              <a:t>Ingress sends / to the frontend and /api to the backend, which uses Postgres</a:t>
             </a:r>
             <a:endParaRPr lang="en-US" sz="1400" dirty="0"/>
           </a:p>
@@ -3480,7 +3570,25 @@
                   <a:schemeClr val="tx1"/>
                 </a:solidFill>
               </a:rPr>
-              <a:t>Dashboard: request rate, p95 latency, error responses, pods up</a:t>
+              <a:t>Live data written through /api</a:t>
+            </a:r>
+            <a:endParaRPr lang="en-US" sz="1400" dirty="0"/>
+          </a:p>
+          <a:p>
+            <a:pPr marL="342900" indent="-342900">
+              <a:spcAft>
+                <a:spcPts val="800"/>
+              </a:spcAft>
+              <a:buSzPct val="100000"/>
+              <a:buChar char="•"/>
+            </a:pPr>
+            <a:r>
+              <a:rPr lang="en-US" sz="1400" dirty="0">
+                <a:solidFill>
+                  <a:schemeClr val="tx1"/>
+                </a:solidFill>
+              </a:rPr>
+              <a:t>Deployed with one helm command</a:t>
             </a:r>
             <a:endParaRPr lang="en-US" sz="1400" dirty="0"/>
           </a:p>
@@ -3588,7 +3696,7 @@
                   <a:schemeClr val="tx1"/>
                 </a:solidFill>
               </a:rPr>
-              <a:t>Troubleshooting</a:t>
+              <a:t>Observability</a:t>
             </a:r>
             <a:endParaRPr lang="en-US" sz="3200" dirty="0"/>
           </a:p>
@@ -3646,7 +3754,7 @@
                   <a:schemeClr val="bg1"/>
                 </a:solidFill>
               </a:rPr>
-              <a:t>FIX</a:t>
+              <a:t>M9</a:t>
             </a:r>
             <a:endParaRPr lang="en-US" sz="1400" dirty="0"/>
           </a:p>
@@ -3654,79 +3762,18 @@
       </p:sp>
       <p:sp>
         <p:nvSpPr>
-          <p:cNvPr id="5" name="Incident 1"/>
+          <p:cNvPr id="5" name="Prometheus targets, both backend pods UP frame"/>
           <p:cNvSpPr/>
           <p:nvPr/>
         </p:nvSpPr>
         <p:spPr>
           <a:xfrm>
-            <a:off x="457200" y="1143000"/>
-            <a:ext cx="4023360" cy="3429000"/>
+            <a:off x="420624" y="1060704"/>
+            <a:ext cx="4050792" cy="2559177"/>
           </a:xfrm>
           <a:prstGeom prst="roundRect">
             <a:avLst>
-              <a:gd name="adj" fmla="val 2667"/>
-            </a:avLst>
-          </a:prstGeom>
-          <a:solidFill>
-            <a:schemeClr val="bg2"/>
-          </a:solidFill>
-          <a:ln/>
-        </p:spPr>
-      </p:sp>
-      <p:sp>
-        <p:nvSpPr>
-          <p:cNvPr id="6" name="Text 4"/>
-          <p:cNvSpPr txBox="1"/>
-          <p:nvPr/>
-        </p:nvSpPr>
-        <p:spPr>
-          <a:xfrm>
-            <a:off x="640080" y="1234440"/>
-            <a:ext cx="3657600" cy="365760"/>
-          </a:xfrm>
-          <a:prstGeom prst="rect">
-            <a:avLst/>
-          </a:prstGeom>
-          <a:noFill/>
-          <a:ln/>
-        </p:spPr>
-        <p:txBody>
-          <a:bodyPr wrap="square" lIns="0" tIns="0" rIns="0" bIns="0" rtlCol="0" anchor="ctr"/>
-          <a:lstStyle/>
-          <a:p>
-            <a:pPr indent="0" marL="0">
-              <a:buNone/>
-            </a:pPr>
-            <a:r>
-              <a:rPr lang="en-US" sz="1800" b="1" dirty="0">
-                <a:solidFill>
-                  <a:schemeClr val="tx1"/>
-                </a:solidFill>
-                <a:latin typeface="Cambria" pitchFamily="34" charset="0"/>
-                <a:ea typeface="Cambria" pitchFamily="34" charset="-122"/>
-                <a:cs typeface="Cambria" pitchFamily="34" charset="-120"/>
-              </a:rPr>
-              <a:t>Bad image tag</a:t>
-            </a:r>
-            <a:endParaRPr lang="en-US" sz="1800" dirty="0"/>
-          </a:p>
-        </p:txBody>
-      </p:sp>
-      <p:sp>
-        <p:nvSpPr>
-          <p:cNvPr id="7" name="Bad image tag terminal output frame"/>
-          <p:cNvSpPr/>
-          <p:nvPr/>
-        </p:nvSpPr>
-        <p:spPr>
-          <a:xfrm>
-            <a:off x="603504" y="1655064"/>
-            <a:ext cx="3730752" cy="932134"/>
-          </a:xfrm>
-          <a:prstGeom prst="roundRect">
-            <a:avLst>
-              <a:gd name="adj" fmla="val 4905"/>
+              <a:gd name="adj" fmla="val 1787"/>
             </a:avLst>
           </a:prstGeom>
           <a:solidFill>
@@ -3749,7 +3796,7 @@
       </p:sp>
       <p:pic>
         <p:nvPicPr>
-          <p:cNvPr id="8" name="Image 0" descr="Bad image tag terminal output">    </p:cNvPr>
+          <p:cNvPr id="6" name="Image 0" descr="Prometheus targets, both backend pods UP">    </p:cNvPr>
           <p:cNvPicPr>
             <a:picLocks noChangeAspect="1"/>
           </p:cNvPicPr>
@@ -3763,8 +3810,8 @@
         </p:blipFill>
         <p:spPr>
           <a:xfrm>
-            <a:off x="640080" y="1691640"/>
-            <a:ext cx="3657600" cy="858982"/>
+            <a:off x="457200" y="1097280"/>
+            <a:ext cx="3977640" cy="2486025"/>
           </a:xfrm>
           <a:prstGeom prst="rect">
             <a:avLst/>
@@ -3773,194 +3820,18 @@
       </p:pic>
       <p:sp>
         <p:nvSpPr>
-          <p:cNvPr id="9" name="Text 6"/>
-          <p:cNvSpPr txBox="1"/>
-          <p:nvPr/>
-        </p:nvSpPr>
-        <p:spPr>
-          <a:xfrm>
-            <a:off x="640080" y="3291840"/>
-            <a:ext cx="3657600" cy="1188720"/>
-          </a:xfrm>
-          <a:prstGeom prst="rect">
-            <a:avLst/>
-          </a:prstGeom>
-          <a:noFill/>
-          <a:ln/>
-        </p:spPr>
-        <p:txBody>
-          <a:bodyPr wrap="square" lIns="0" tIns="0" rIns="0" bIns="0" rtlCol="0" anchor="t"/>
-          <a:lstStyle/>
-          <a:p>
-            <a:pPr indent="0" marL="0">
-              <a:spcAft>
-                <a:spcPts val="400"/>
-              </a:spcAft>
-              <a:buNone/>
-            </a:pPr>
-            <a:r>
-              <a:rPr lang="en-US" sz="1200" b="1" dirty="0">
-                <a:solidFill>
-                  <a:schemeClr val="tx1"/>
-                </a:solidFill>
-              </a:rPr>
-              <a:t>Symptom: </a:t>
-            </a:r>
-            <a:pPr indent="0" marL="0">
-              <a:spcAft>
-                <a:spcPts val="400"/>
-              </a:spcAft>
-              <a:buNone/>
-            </a:pPr>
-            <a:r>
-              <a:rPr lang="en-US" sz="1200" dirty="0">
-                <a:solidFill>
-                  <a:schemeClr val="tx1"/>
-                </a:solidFill>
-              </a:rPr>
-              <a:t>ImagePullBackOff</a:t>
-            </a:r>
-            <a:endParaRPr lang="en-US" sz="1200" dirty="0"/>
-          </a:p>
-          <a:p>
-            <a:pPr indent="0" marL="0">
-              <a:spcAft>
-                <a:spcPts val="400"/>
-              </a:spcAft>
-              <a:buNone/>
-            </a:pPr>
-            <a:r>
-              <a:rPr lang="en-US" sz="1200" b="1" dirty="0">
-                <a:solidFill>
-                  <a:schemeClr val="tx1"/>
-                </a:solidFill>
-              </a:rPr>
-              <a:t>Cause: </a:t>
-            </a:r>
-            <a:pPr indent="0" marL="0">
-              <a:spcAft>
-                <a:spcPts val="400"/>
-              </a:spcAft>
-              <a:buNone/>
-            </a:pPr>
-            <a:r>
-              <a:rPr lang="en-US" sz="1200" dirty="0">
-                <a:solidFill>
-                  <a:schemeClr val="tx1"/>
-                </a:solidFill>
-              </a:rPr>
-              <a:t>Tag does not exist in the registry</a:t>
-            </a:r>
-            <a:endParaRPr lang="en-US" sz="1200" dirty="0"/>
-          </a:p>
-          <a:p>
-            <a:pPr indent="0" marL="0">
-              <a:spcAft>
-                <a:spcPts val="400"/>
-              </a:spcAft>
-              <a:buNone/>
-            </a:pPr>
-            <a:r>
-              <a:rPr lang="en-US" sz="1200" b="1" dirty="0">
-                <a:solidFill>
-                  <a:schemeClr val="tx1"/>
-                </a:solidFill>
-              </a:rPr>
-              <a:t>Fix: </a:t>
-            </a:r>
-            <a:pPr indent="0" marL="0">
-              <a:spcAft>
-                <a:spcPts val="400"/>
-              </a:spcAft>
-              <a:buNone/>
-            </a:pPr>
-            <a:r>
-              <a:rPr lang="en-US" sz="1200" dirty="0">
-                <a:solidFill>
-                  <a:schemeClr val="tx1"/>
-                </a:solidFill>
-              </a:rPr>
-              <a:t>Point the Deployment at a real tag</a:t>
-            </a:r>
-            <a:endParaRPr lang="en-US" sz="1200" dirty="0"/>
-          </a:p>
-        </p:txBody>
-      </p:sp>
-      <p:sp>
-        <p:nvSpPr>
-          <p:cNvPr id="10" name="Incident 2"/>
+          <p:cNvPr id="7" name="Grafana dashboard with live panels frame"/>
           <p:cNvSpPr/>
           <p:nvPr/>
         </p:nvSpPr>
         <p:spPr>
           <a:xfrm>
-            <a:off x="4663440" y="1143000"/>
-            <a:ext cx="4023360" cy="3429000"/>
+            <a:off x="4672584" y="1060704"/>
+            <a:ext cx="4050792" cy="2559177"/>
           </a:xfrm>
           <a:prstGeom prst="roundRect">
             <a:avLst>
-              <a:gd name="adj" fmla="val 2667"/>
-            </a:avLst>
-          </a:prstGeom>
-          <a:solidFill>
-            <a:schemeClr val="bg2"/>
-          </a:solidFill>
-          <a:ln/>
-        </p:spPr>
-      </p:sp>
-      <p:sp>
-        <p:nvSpPr>
-          <p:cNvPr id="11" name="Text 8"/>
-          <p:cNvSpPr txBox="1"/>
-          <p:nvPr/>
-        </p:nvSpPr>
-        <p:spPr>
-          <a:xfrm>
-            <a:off x="4846320" y="1234440"/>
-            <a:ext cx="3657600" cy="365760"/>
-          </a:xfrm>
-          <a:prstGeom prst="rect">
-            <a:avLst/>
-          </a:prstGeom>
-          <a:noFill/>
-          <a:ln/>
-        </p:spPr>
-        <p:txBody>
-          <a:bodyPr wrap="square" lIns="0" tIns="0" rIns="0" bIns="0" rtlCol="0" anchor="ctr"/>
-          <a:lstStyle/>
-          <a:p>
-            <a:pPr indent="0" marL="0">
-              <a:buNone/>
-            </a:pPr>
-            <a:r>
-              <a:rPr lang="en-US" sz="1800" b="1" dirty="0">
-                <a:solidFill>
-                  <a:schemeClr val="tx1"/>
-                </a:solidFill>
-                <a:latin typeface="Cambria" pitchFamily="34" charset="0"/>
-                <a:ea typeface="Cambria" pitchFamily="34" charset="-122"/>
-                <a:cs typeface="Cambria" pitchFamily="34" charset="-120"/>
-              </a:rPr>
-              <a:t>Selector mismatch</a:t>
-            </a:r>
-            <a:endParaRPr lang="en-US" sz="1800" dirty="0"/>
-          </a:p>
-        </p:txBody>
-      </p:sp>
-      <p:sp>
-        <p:nvSpPr>
-          <p:cNvPr id="12" name="Selector mismatch terminal output frame"/>
-          <p:cNvSpPr/>
-          <p:nvPr/>
-        </p:nvSpPr>
-        <p:spPr>
-          <a:xfrm>
-            <a:off x="4809744" y="1655064"/>
-            <a:ext cx="3018954" cy="1536192"/>
-          </a:xfrm>
-          <a:prstGeom prst="roundRect">
-            <a:avLst>
-              <a:gd name="adj" fmla="val 2976"/>
+              <a:gd name="adj" fmla="val 1787"/>
             </a:avLst>
           </a:prstGeom>
           <a:solidFill>
@@ -3983,7 +3854,7 @@
       </p:sp>
       <p:pic>
         <p:nvPicPr>
-          <p:cNvPr id="13" name="Image 1" descr="Selector mismatch terminal output">    </p:cNvPr>
+          <p:cNvPr id="8" name="Image 1" descr="Grafana dashboard with live panels">    </p:cNvPr>
           <p:cNvPicPr>
             <a:picLocks noChangeAspect="1"/>
           </p:cNvPicPr>
@@ -3997,8 +3868,8 @@
         </p:blipFill>
         <p:spPr>
           <a:xfrm>
-            <a:off x="4846320" y="1691640"/>
-            <a:ext cx="2945802" cy="1463040"/>
+            <a:off x="4709160" y="1097280"/>
+            <a:ext cx="3977640" cy="2486025"/>
           </a:xfrm>
           <a:prstGeom prst="rect">
             <a:avLst/>
@@ -4007,14 +3878,14 @@
       </p:pic>
       <p:sp>
         <p:nvSpPr>
-          <p:cNvPr id="14" name="Text 10"/>
+          <p:cNvPr id="9" name="Text 5"/>
           <p:cNvSpPr txBox="1"/>
           <p:nvPr/>
         </p:nvSpPr>
         <p:spPr>
           <a:xfrm>
-            <a:off x="4846320" y="3291840"/>
-            <a:ext cx="3657600" cy="1188720"/>
+            <a:off x="457200" y="3794760"/>
+            <a:ext cx="8229600" cy="914400"/>
           </a:xfrm>
           <a:prstGeom prst="rect">
             <a:avLst/>
@@ -4026,97 +3897,40 @@
           <a:bodyPr wrap="square" lIns="0" tIns="0" rIns="0" bIns="0" rtlCol="0" anchor="t"/>
           <a:lstStyle/>
           <a:p>
-            <a:pPr indent="0" marL="0">
+            <a:pPr marL="342900" indent="-342900">
               <a:spcAft>
-                <a:spcPts val="400"/>
+                <a:spcPts val="800"/>
               </a:spcAft>
-              <a:buNone/>
-            </a:pPr>
-            <a:r>
-              <a:rPr lang="en-US" sz="1200" b="1" dirty="0">
+              <a:buSzPct val="100000"/>
+              <a:buChar char="•"/>
+            </a:pPr>
+            <a:r>
+              <a:rPr lang="en-US" sz="1400" dirty="0">
                 <a:solidFill>
                   <a:schemeClr val="tx1"/>
                 </a:solidFill>
               </a:rPr>
-              <a:t>Symptom: </a:t>
-            </a:r>
-            <a:pPr indent="0" marL="0">
+              <a:t>/metrics exposed by FastAPI; ServiceMonitor makes Prometheus scrape both pods</a:t>
+            </a:r>
+            <a:endParaRPr lang="en-US" sz="1400" dirty="0"/>
+          </a:p>
+          <a:p>
+            <a:pPr marL="342900" indent="-342900">
               <a:spcAft>
-                <a:spcPts val="400"/>
+                <a:spcPts val="800"/>
               </a:spcAft>
-              <a:buNone/>
-            </a:pPr>
-            <a:r>
-              <a:rPr lang="en-US" sz="1200" dirty="0">
+              <a:buSzPct val="100000"/>
+              <a:buChar char="•"/>
+            </a:pPr>
+            <a:r>
+              <a:rPr lang="en-US" sz="1400" dirty="0">
                 <a:solidFill>
                   <a:schemeClr val="tx1"/>
                 </a:solidFill>
               </a:rPr>
-              <a:t>Pod Running, endpoints &lt;none&gt;</a:t>
-            </a:r>
-            <a:endParaRPr lang="en-US" sz="1200" dirty="0"/>
-          </a:p>
-          <a:p>
-            <a:pPr indent="0" marL="0">
-              <a:spcAft>
-                <a:spcPts val="400"/>
-              </a:spcAft>
-              <a:buNone/>
-            </a:pPr>
-            <a:r>
-              <a:rPr lang="en-US" sz="1200" b="1" dirty="0">
-                <a:solidFill>
-                  <a:schemeClr val="tx1"/>
-                </a:solidFill>
-              </a:rPr>
-              <a:t>Cause: </a:t>
-            </a:r>
-            <a:pPr indent="0" marL="0">
-              <a:spcAft>
-                <a:spcPts val="400"/>
-              </a:spcAft>
-              <a:buNone/>
-            </a:pPr>
-            <a:r>
-              <a:rPr lang="en-US" sz="1200" dirty="0">
-                <a:solidFill>
-                  <a:schemeClr val="tx1"/>
-                </a:solidFill>
-              </a:rPr>
-              <a:t>Service selector app=tb-service, pod label app=tb-svc</a:t>
-            </a:r>
-            <a:endParaRPr lang="en-US" sz="1200" dirty="0"/>
-          </a:p>
-          <a:p>
-            <a:pPr indent="0" marL="0">
-              <a:spcAft>
-                <a:spcPts val="400"/>
-              </a:spcAft>
-              <a:buNone/>
-            </a:pPr>
-            <a:r>
-              <a:rPr lang="en-US" sz="1200" b="1" dirty="0">
-                <a:solidFill>
-                  <a:schemeClr val="tx1"/>
-                </a:solidFill>
-              </a:rPr>
-              <a:t>Fix: </a:t>
-            </a:r>
-            <a:pPr indent="0" marL="0">
-              <a:spcAft>
-                <a:spcPts val="400"/>
-              </a:spcAft>
-              <a:buNone/>
-            </a:pPr>
-            <a:r>
-              <a:rPr lang="en-US" sz="1200" dirty="0">
-                <a:solidFill>
-                  <a:schemeClr val="tx1"/>
-                </a:solidFill>
-              </a:rPr>
-              <a:t>Patch the selector to match</a:t>
-            </a:r>
-            <a:endParaRPr lang="en-US" sz="1200" dirty="0"/>
+              <a:t>Dashboard: request rate, p95 latency, error responses, pods up</a:t>
+            </a:r>
+            <a:endParaRPr lang="en-US" sz="1400" dirty="0"/>
           </a:p>
         </p:txBody>
       </p:sp>
@@ -4222,7 +4036,7 @@
                   <a:schemeClr val="tx1"/>
                 </a:solidFill>
               </a:rPr>
-              <a:t>Live demo flow</a:t>
+              <a:t>Troubleshooting</a:t>
             </a:r>
             <a:endParaRPr lang="en-US" sz="3200" dirty="0"/>
           </a:p>
@@ -4237,7 +4051,7 @@
         <p:spPr>
           <a:xfrm>
             <a:off x="457200" y="420624"/>
-            <a:ext cx="777240" cy="457200"/>
+            <a:ext cx="640080" cy="457200"/>
           </a:xfrm>
           <a:prstGeom prst="roundRect">
             <a:avLst>
@@ -4259,7 +4073,7 @@
         <p:spPr>
           <a:xfrm>
             <a:off x="457200" y="420624"/>
-            <a:ext cx="777240" cy="457200"/>
+            <a:ext cx="640080" cy="457200"/>
           </a:xfrm>
           <a:prstGeom prst="rect">
             <a:avLst/>
@@ -4280,7 +4094,7 @@
                   <a:schemeClr val="bg1"/>
                 </a:solidFill>
               </a:rPr>
-              <a:t>DEMO</a:t>
+              <a:t>FIX</a:t>
             </a:r>
             <a:endParaRPr lang="en-US" sz="1400" dirty="0"/>
           </a:p>
@@ -4288,20 +4102,22 @@
       </p:sp>
       <p:sp>
         <p:nvSpPr>
-          <p:cNvPr id="5" name="Demo step 1"/>
+          <p:cNvPr id="5" name="Incident 1"/>
           <p:cNvSpPr/>
           <p:nvPr/>
         </p:nvSpPr>
         <p:spPr>
           <a:xfrm>
-            <a:off x="960120" y="1325880"/>
-            <a:ext cx="548640" cy="548640"/>
-          </a:xfrm>
-          <a:prstGeom prst="ellipse">
-            <a:avLst/>
+            <a:off x="457200" y="1143000"/>
+            <a:ext cx="4023360" cy="3429000"/>
+          </a:xfrm>
+          <a:prstGeom prst="roundRect">
+            <a:avLst>
+              <a:gd name="adj" fmla="val 2667"/>
+            </a:avLst>
           </a:prstGeom>
           <a:solidFill>
-            <a:schemeClr val="accent1"/>
+            <a:schemeClr val="bg2"/>
           </a:solidFill>
           <a:ln/>
         </p:spPr>
@@ -4314,8 +4130,8 @@
         </p:nvSpPr>
         <p:spPr>
           <a:xfrm>
-            <a:off x="960120" y="1325880"/>
-            <a:ext cx="548640" cy="548640"/>
+            <a:off x="640080" y="1234440"/>
+            <a:ext cx="3657600" cy="365760"/>
           </a:xfrm>
           <a:prstGeom prst="rect">
             <a:avLst/>
@@ -4327,31 +4143,92 @@
           <a:bodyPr wrap="square" lIns="0" tIns="0" rIns="0" bIns="0" rtlCol="0" anchor="ctr"/>
           <a:lstStyle/>
           <a:p>
-            <a:pPr algn="ctr" indent="0" marL="0">
-              <a:buNone/>
-            </a:pPr>
-            <a:r>
-              <a:rPr lang="en-US" sz="2000" b="1" dirty="0">
-                <a:solidFill>
-                  <a:schemeClr val="bg1"/>
-                </a:solidFill>
-              </a:rPr>
-              <a:t>1</a:t>
-            </a:r>
-            <a:endParaRPr lang="en-US" sz="2000" dirty="0"/>
-          </a:p>
-        </p:txBody>
-      </p:sp>
-      <p:sp>
-        <p:nvSpPr>
-          <p:cNvPr id="7" name="Text 5"/>
+            <a:pPr indent="0" marL="0">
+              <a:buNone/>
+            </a:pPr>
+            <a:r>
+              <a:rPr lang="en-US" sz="1800" b="1" dirty="0">
+                <a:solidFill>
+                  <a:schemeClr val="tx1"/>
+                </a:solidFill>
+                <a:latin typeface="Cambria" pitchFamily="34" charset="0"/>
+                <a:ea typeface="Cambria" pitchFamily="34" charset="-122"/>
+                <a:cs typeface="Cambria" pitchFamily="34" charset="-120"/>
+              </a:rPr>
+              <a:t>Bad image tag</a:t>
+            </a:r>
+            <a:endParaRPr lang="en-US" sz="1800" dirty="0"/>
+          </a:p>
+        </p:txBody>
+      </p:sp>
+      <p:sp>
+        <p:nvSpPr>
+          <p:cNvPr id="7" name="Bad image tag terminal output frame"/>
+          <p:cNvSpPr/>
+          <p:nvPr/>
+        </p:nvSpPr>
+        <p:spPr>
+          <a:xfrm>
+            <a:off x="603504" y="1655064"/>
+            <a:ext cx="3730752" cy="932134"/>
+          </a:xfrm>
+          <a:prstGeom prst="roundRect">
+            <a:avLst>
+              <a:gd name="adj" fmla="val 4905"/>
+            </a:avLst>
+          </a:prstGeom>
+          <a:solidFill>
+            <a:schemeClr val="bg1"/>
+          </a:solidFill>
+          <a:ln w="9525">
+            <a:solidFill>
+              <a:schemeClr val="accent6"/>
+            </a:solidFill>
+            <a:prstDash val="solid"/>
+          </a:ln>
+          <a:effectLst>
+            <a:outerShdw sx="100000" sy="100000" kx="0" ky="0" algn="bl" rotWithShape="0" blurRad="76200" dist="25400" dir="5400000">
+              <a:srgbClr val="000000">
+                <a:alpha val="18000"/>
+              </a:srgbClr>
+            </a:outerShdw>
+          </a:effectLst>
+        </p:spPr>
+      </p:sp>
+      <p:pic>
+        <p:nvPicPr>
+          <p:cNvPr id="8" name="Image 0" descr="Bad image tag terminal output">    </p:cNvPr>
+          <p:cNvPicPr>
+            <a:picLocks noChangeAspect="1"/>
+          </p:cNvPicPr>
+          <p:nvPr/>
+        </p:nvPicPr>
+        <p:blipFill>
+          <a:blip r:embed="rId1"/>
+          <a:stretch>
+            <a:fillRect/>
+          </a:stretch>
+        </p:blipFill>
+        <p:spPr>
+          <a:xfrm>
+            <a:off x="640080" y="1691640"/>
+            <a:ext cx="3657600" cy="858982"/>
+          </a:xfrm>
+          <a:prstGeom prst="rect">
+            <a:avLst/>
+          </a:prstGeom>
+        </p:spPr>
+      </p:pic>
+      <p:sp>
+        <p:nvSpPr>
+          <p:cNvPr id="9" name="Text 6"/>
           <p:cNvSpPr txBox="1"/>
           <p:nvPr/>
         </p:nvSpPr>
         <p:spPr>
           <a:xfrm>
-            <a:off x="457200" y="2057400"/>
-            <a:ext cx="1554480" cy="731520"/>
+            <a:off x="640080" y="3291840"/>
+            <a:ext cx="3657600" cy="1188720"/>
           </a:xfrm>
           <a:prstGeom prst="rect">
             <a:avLst/>
@@ -4363,31 +4240,229 @@
           <a:bodyPr wrap="square" lIns="0" tIns="0" rIns="0" bIns="0" rtlCol="0" anchor="t"/>
           <a:lstStyle/>
           <a:p>
-            <a:pPr algn="ctr" indent="0" marL="0">
-              <a:buNone/>
-            </a:pPr>
-            <a:r>
-              <a:rPr lang="en-US" sz="1400" b="1" dirty="0">
+            <a:pPr indent="0" marL="0">
+              <a:spcAft>
+                <a:spcPts val="400"/>
+              </a:spcAft>
+              <a:buNone/>
+            </a:pPr>
+            <a:r>
+              <a:rPr lang="en-US" sz="1200" b="1" dirty="0">
                 <a:solidFill>
                   <a:schemeClr val="tx1"/>
                 </a:solidFill>
               </a:rPr>
-              <a:t>Edit a visible string</a:t>
-            </a:r>
-            <a:endParaRPr lang="en-US" sz="1400" dirty="0"/>
-          </a:p>
-        </p:txBody>
-      </p:sp>
-      <p:sp>
-        <p:nvSpPr>
-          <p:cNvPr id="8" name="Text 6"/>
+              <a:t>Symptom: </a:t>
+            </a:r>
+            <a:pPr indent="0" marL="0">
+              <a:spcAft>
+                <a:spcPts val="400"/>
+              </a:spcAft>
+              <a:buNone/>
+            </a:pPr>
+            <a:r>
+              <a:rPr lang="en-US" sz="1200" dirty="0">
+                <a:solidFill>
+                  <a:schemeClr val="tx1"/>
+                </a:solidFill>
+              </a:rPr>
+              <a:t>ImagePullBackOff</a:t>
+            </a:r>
+            <a:endParaRPr lang="en-US" sz="1200" dirty="0"/>
+          </a:p>
+          <a:p>
+            <a:pPr indent="0" marL="0">
+              <a:spcAft>
+                <a:spcPts val="400"/>
+              </a:spcAft>
+              <a:buNone/>
+            </a:pPr>
+            <a:r>
+              <a:rPr lang="en-US" sz="1200" b="1" dirty="0">
+                <a:solidFill>
+                  <a:schemeClr val="tx1"/>
+                </a:solidFill>
+              </a:rPr>
+              <a:t>Cause: </a:t>
+            </a:r>
+            <a:pPr indent="0" marL="0">
+              <a:spcAft>
+                <a:spcPts val="400"/>
+              </a:spcAft>
+              <a:buNone/>
+            </a:pPr>
+            <a:r>
+              <a:rPr lang="en-US" sz="1200" dirty="0">
+                <a:solidFill>
+                  <a:schemeClr val="tx1"/>
+                </a:solidFill>
+              </a:rPr>
+              <a:t>Tag does not exist in the registry</a:t>
+            </a:r>
+            <a:endParaRPr lang="en-US" sz="1200" dirty="0"/>
+          </a:p>
+          <a:p>
+            <a:pPr indent="0" marL="0">
+              <a:spcAft>
+                <a:spcPts val="400"/>
+              </a:spcAft>
+              <a:buNone/>
+            </a:pPr>
+            <a:r>
+              <a:rPr lang="en-US" sz="1200" b="1" dirty="0">
+                <a:solidFill>
+                  <a:schemeClr val="tx1"/>
+                </a:solidFill>
+              </a:rPr>
+              <a:t>Fix: </a:t>
+            </a:r>
+            <a:pPr indent="0" marL="0">
+              <a:spcAft>
+                <a:spcPts val="400"/>
+              </a:spcAft>
+              <a:buNone/>
+            </a:pPr>
+            <a:r>
+              <a:rPr lang="en-US" sz="1200" dirty="0">
+                <a:solidFill>
+                  <a:schemeClr val="tx1"/>
+                </a:solidFill>
+              </a:rPr>
+              <a:t>Point the Deployment at a real tag</a:t>
+            </a:r>
+            <a:endParaRPr lang="en-US" sz="1200" dirty="0"/>
+          </a:p>
+        </p:txBody>
+      </p:sp>
+      <p:sp>
+        <p:nvSpPr>
+          <p:cNvPr id="10" name="Incident 2"/>
+          <p:cNvSpPr/>
+          <p:nvPr/>
+        </p:nvSpPr>
+        <p:spPr>
+          <a:xfrm>
+            <a:off x="4663440" y="1143000"/>
+            <a:ext cx="4023360" cy="3429000"/>
+          </a:xfrm>
+          <a:prstGeom prst="roundRect">
+            <a:avLst>
+              <a:gd name="adj" fmla="val 2667"/>
+            </a:avLst>
+          </a:prstGeom>
+          <a:solidFill>
+            <a:schemeClr val="bg2"/>
+          </a:solidFill>
+          <a:ln/>
+        </p:spPr>
+      </p:sp>
+      <p:sp>
+        <p:nvSpPr>
+          <p:cNvPr id="11" name="Text 8"/>
           <p:cNvSpPr txBox="1"/>
           <p:nvPr/>
         </p:nvSpPr>
         <p:spPr>
           <a:xfrm>
-            <a:off x="457200" y="2788920"/>
-            <a:ext cx="1554480" cy="640080"/>
+            <a:off x="4846320" y="1234440"/>
+            <a:ext cx="3657600" cy="365760"/>
+          </a:xfrm>
+          <a:prstGeom prst="rect">
+            <a:avLst/>
+          </a:prstGeom>
+          <a:noFill/>
+          <a:ln/>
+        </p:spPr>
+        <p:txBody>
+          <a:bodyPr wrap="square" lIns="0" tIns="0" rIns="0" bIns="0" rtlCol="0" anchor="ctr"/>
+          <a:lstStyle/>
+          <a:p>
+            <a:pPr indent="0" marL="0">
+              <a:buNone/>
+            </a:pPr>
+            <a:r>
+              <a:rPr lang="en-US" sz="1800" b="1" dirty="0">
+                <a:solidFill>
+                  <a:schemeClr val="tx1"/>
+                </a:solidFill>
+                <a:latin typeface="Cambria" pitchFamily="34" charset="0"/>
+                <a:ea typeface="Cambria" pitchFamily="34" charset="-122"/>
+                <a:cs typeface="Cambria" pitchFamily="34" charset="-120"/>
+              </a:rPr>
+              <a:t>Selector mismatch</a:t>
+            </a:r>
+            <a:endParaRPr lang="en-US" sz="1800" dirty="0"/>
+          </a:p>
+        </p:txBody>
+      </p:sp>
+      <p:sp>
+        <p:nvSpPr>
+          <p:cNvPr id="12" name="Selector mismatch terminal output frame"/>
+          <p:cNvSpPr/>
+          <p:nvPr/>
+        </p:nvSpPr>
+        <p:spPr>
+          <a:xfrm>
+            <a:off x="4809744" y="1655064"/>
+            <a:ext cx="3018954" cy="1536192"/>
+          </a:xfrm>
+          <a:prstGeom prst="roundRect">
+            <a:avLst>
+              <a:gd name="adj" fmla="val 2976"/>
+            </a:avLst>
+          </a:prstGeom>
+          <a:solidFill>
+            <a:schemeClr val="bg1"/>
+          </a:solidFill>
+          <a:ln w="9525">
+            <a:solidFill>
+              <a:schemeClr val="accent6"/>
+            </a:solidFill>
+            <a:prstDash val="solid"/>
+          </a:ln>
+          <a:effectLst>
+            <a:outerShdw sx="100000" sy="100000" kx="0" ky="0" algn="bl" rotWithShape="0" blurRad="76200" dist="25400" dir="5400000">
+              <a:srgbClr val="000000">
+                <a:alpha val="18000"/>
+              </a:srgbClr>
+            </a:outerShdw>
+          </a:effectLst>
+        </p:spPr>
+      </p:sp>
+      <p:pic>
+        <p:nvPicPr>
+          <p:cNvPr id="13" name="Image 1" descr="Selector mismatch terminal output">    </p:cNvPr>
+          <p:cNvPicPr>
+            <a:picLocks noChangeAspect="1"/>
+          </p:cNvPicPr>
+          <p:nvPr/>
+        </p:nvPicPr>
+        <p:blipFill>
+          <a:blip r:embed="rId2"/>
+          <a:stretch>
+            <a:fillRect/>
+          </a:stretch>
+        </p:blipFill>
+        <p:spPr>
+          <a:xfrm>
+            <a:off x="4846320" y="1691640"/>
+            <a:ext cx="2945802" cy="1463040"/>
+          </a:xfrm>
+          <a:prstGeom prst="rect">
+            <a:avLst/>
+          </a:prstGeom>
+        </p:spPr>
+      </p:pic>
+      <p:sp>
+        <p:nvSpPr>
+          <p:cNvPr id="14" name="Text 10"/>
+          <p:cNvSpPr txBox="1"/>
+          <p:nvPr/>
+        </p:nvSpPr>
+        <p:spPr>
+          <a:xfrm>
+            <a:off x="4846320" y="3291840"/>
+            <a:ext cx="3657600" cy="1188720"/>
           </a:xfrm>
           <a:prstGeom prst="rect">
             <a:avLst/>
@@ -4399,566 +4474,97 @@
           <a:bodyPr wrap="square" lIns="0" tIns="0" rIns="0" bIns="0" rtlCol="0" anchor="t"/>
           <a:lstStyle/>
           <a:p>
-            <a:pPr algn="ctr" indent="0" marL="0">
+            <a:pPr indent="0" marL="0">
+              <a:spcAft>
+                <a:spcPts val="400"/>
+              </a:spcAft>
+              <a:buNone/>
+            </a:pPr>
+            <a:r>
+              <a:rPr lang="en-US" sz="1200" b="1" dirty="0">
+                <a:solidFill>
+                  <a:schemeClr val="tx1"/>
+                </a:solidFill>
+              </a:rPr>
+              <a:t>Symptom: </a:t>
+            </a:r>
+            <a:pPr indent="0" marL="0">
+              <a:spcAft>
+                <a:spcPts val="400"/>
+              </a:spcAft>
               <a:buNone/>
             </a:pPr>
             <a:r>
               <a:rPr lang="en-US" sz="1200" dirty="0">
                 <a:solidFill>
-                  <a:schemeClr val="accent6"/>
-                </a:solidFill>
-              </a:rPr>
-              <a:t>frontend/src/App.jsx</a:t>
+                  <a:schemeClr val="tx1"/>
+                </a:solidFill>
+              </a:rPr>
+              <a:t>Pod Running, endpoints &lt;none&gt;</a:t>
             </a:r>
             <a:endParaRPr lang="en-US" sz="1200" dirty="0"/>
           </a:p>
-        </p:txBody>
-      </p:sp>
-      <p:sp>
-        <p:nvSpPr>
-          <p:cNvPr id="9" name="Demo step 2"/>
-          <p:cNvSpPr/>
-          <p:nvPr/>
-        </p:nvSpPr>
-        <p:spPr>
-          <a:xfrm>
-            <a:off x="2624328" y="1325880"/>
-            <a:ext cx="548640" cy="548640"/>
-          </a:xfrm>
-          <a:prstGeom prst="ellipse">
-            <a:avLst/>
-          </a:prstGeom>
-          <a:solidFill>
-            <a:schemeClr val="accent1"/>
-          </a:solidFill>
-          <a:ln/>
-        </p:spPr>
-      </p:sp>
-      <p:sp>
-        <p:nvSpPr>
-          <p:cNvPr id="10" name="Text 8"/>
-          <p:cNvSpPr txBox="1"/>
-          <p:nvPr/>
-        </p:nvSpPr>
-        <p:spPr>
-          <a:xfrm>
-            <a:off x="2624328" y="1325880"/>
-            <a:ext cx="548640" cy="548640"/>
-          </a:xfrm>
-          <a:prstGeom prst="rect">
-            <a:avLst/>
-          </a:prstGeom>
-          <a:noFill/>
-          <a:ln/>
-        </p:spPr>
-        <p:txBody>
-          <a:bodyPr wrap="square" lIns="0" tIns="0" rIns="0" bIns="0" rtlCol="0" anchor="ctr"/>
-          <a:lstStyle/>
-          <a:p>
-            <a:pPr algn="ctr" indent="0" marL="0">
-              <a:buNone/>
-            </a:pPr>
-            <a:r>
-              <a:rPr lang="en-US" sz="2000" b="1" dirty="0">
-                <a:solidFill>
-                  <a:schemeClr val="bg1"/>
-                </a:solidFill>
-              </a:rPr>
-              <a:t>2</a:t>
-            </a:r>
-            <a:endParaRPr lang="en-US" sz="2000" dirty="0"/>
-          </a:p>
-        </p:txBody>
-      </p:sp>
-      <p:sp>
-        <p:nvSpPr>
-          <p:cNvPr id="11" name="Text 9"/>
-          <p:cNvSpPr txBox="1"/>
-          <p:nvPr/>
-        </p:nvSpPr>
-        <p:spPr>
-          <a:xfrm>
-            <a:off x="2121408" y="2057400"/>
-            <a:ext cx="1554480" cy="731520"/>
-          </a:xfrm>
-          <a:prstGeom prst="rect">
-            <a:avLst/>
-          </a:prstGeom>
-          <a:noFill/>
-          <a:ln/>
-        </p:spPr>
-        <p:txBody>
-          <a:bodyPr wrap="square" lIns="0" tIns="0" rIns="0" bIns="0" rtlCol="0" anchor="t"/>
-          <a:lstStyle/>
-          <a:p>
-            <a:pPr algn="ctr" indent="0" marL="0">
-              <a:buNone/>
-            </a:pPr>
-            <a:r>
-              <a:rPr lang="en-US" sz="1400" b="1" dirty="0">
+          <a:p>
+            <a:pPr indent="0" marL="0">
+              <a:spcAft>
+                <a:spcPts val="400"/>
+              </a:spcAft>
+              <a:buNone/>
+            </a:pPr>
+            <a:r>
+              <a:rPr lang="en-US" sz="1200" b="1" dirty="0">
                 <a:solidFill>
                   <a:schemeClr val="tx1"/>
                 </a:solidFill>
               </a:rPr>
-              <a:t>git commit and push</a:t>
-            </a:r>
-            <a:endParaRPr lang="en-US" sz="1400" dirty="0"/>
-          </a:p>
-        </p:txBody>
-      </p:sp>
-      <p:sp>
-        <p:nvSpPr>
-          <p:cNvPr id="12" name="Text 10"/>
-          <p:cNvSpPr txBox="1"/>
-          <p:nvPr/>
-        </p:nvSpPr>
-        <p:spPr>
-          <a:xfrm>
-            <a:off x="2121408" y="2788920"/>
-            <a:ext cx="1554480" cy="640080"/>
-          </a:xfrm>
-          <a:prstGeom prst="rect">
-            <a:avLst/>
-          </a:prstGeom>
-          <a:noFill/>
-          <a:ln/>
-        </p:spPr>
-        <p:txBody>
-          <a:bodyPr wrap="square" lIns="0" tIns="0" rIns="0" bIns="0" rtlCol="0" anchor="t"/>
-          <a:lstStyle/>
-          <a:p>
-            <a:pPr algn="ctr" indent="0" marL="0">
+              <a:t>Cause: </a:t>
+            </a:r>
+            <a:pPr indent="0" marL="0">
+              <a:spcAft>
+                <a:spcPts val="400"/>
+              </a:spcAft>
               <a:buNone/>
             </a:pPr>
             <a:r>
               <a:rPr lang="en-US" sz="1200" dirty="0">
                 <a:solidFill>
-                  <a:schemeClr val="accent6"/>
-                </a:solidFill>
-              </a:rPr>
-              <a:t>triggers Actions</a:t>
+                  <a:schemeClr val="tx1"/>
+                </a:solidFill>
+              </a:rPr>
+              <a:t>Service selector app=tb-service, pod label app=tb-svc</a:t>
             </a:r>
             <a:endParaRPr lang="en-US" sz="1200" dirty="0"/>
           </a:p>
-        </p:txBody>
-      </p:sp>
-      <p:sp>
-        <p:nvSpPr>
-          <p:cNvPr id="13" name="Demo step 3"/>
-          <p:cNvSpPr/>
-          <p:nvPr/>
-        </p:nvSpPr>
-        <p:spPr>
-          <a:xfrm>
-            <a:off x="4288536" y="1325880"/>
-            <a:ext cx="548640" cy="548640"/>
-          </a:xfrm>
-          <a:prstGeom prst="ellipse">
-            <a:avLst/>
-          </a:prstGeom>
-          <a:solidFill>
-            <a:schemeClr val="accent1"/>
-          </a:solidFill>
-          <a:ln/>
-        </p:spPr>
-      </p:sp>
-      <p:sp>
-        <p:nvSpPr>
-          <p:cNvPr id="14" name="Text 12"/>
-          <p:cNvSpPr txBox="1"/>
-          <p:nvPr/>
-        </p:nvSpPr>
-        <p:spPr>
-          <a:xfrm>
-            <a:off x="4288536" y="1325880"/>
-            <a:ext cx="548640" cy="548640"/>
-          </a:xfrm>
-          <a:prstGeom prst="rect">
-            <a:avLst/>
-          </a:prstGeom>
-          <a:noFill/>
-          <a:ln/>
-        </p:spPr>
-        <p:txBody>
-          <a:bodyPr wrap="square" lIns="0" tIns="0" rIns="0" bIns="0" rtlCol="0" anchor="ctr"/>
-          <a:lstStyle/>
-          <a:p>
-            <a:pPr algn="ctr" indent="0" marL="0">
-              <a:buNone/>
-            </a:pPr>
-            <a:r>
-              <a:rPr lang="en-US" sz="2000" b="1" dirty="0">
-                <a:solidFill>
-                  <a:schemeClr val="bg1"/>
-                </a:solidFill>
-              </a:rPr>
-              <a:t>3</a:t>
-            </a:r>
-            <a:endParaRPr lang="en-US" sz="2000" dirty="0"/>
-          </a:p>
-        </p:txBody>
-      </p:sp>
-      <p:sp>
-        <p:nvSpPr>
-          <p:cNvPr id="15" name="Text 13"/>
-          <p:cNvSpPr txBox="1"/>
-          <p:nvPr/>
-        </p:nvSpPr>
-        <p:spPr>
-          <a:xfrm>
-            <a:off x="3785616" y="2057400"/>
-            <a:ext cx="1554480" cy="731520"/>
-          </a:xfrm>
-          <a:prstGeom prst="rect">
-            <a:avLst/>
-          </a:prstGeom>
-          <a:noFill/>
-          <a:ln/>
-        </p:spPr>
-        <p:txBody>
-          <a:bodyPr wrap="square" lIns="0" tIns="0" rIns="0" bIns="0" rtlCol="0" anchor="t"/>
-          <a:lstStyle/>
-          <a:p>
-            <a:pPr algn="ctr" indent="0" marL="0">
-              <a:buNone/>
-            </a:pPr>
-            <a:r>
-              <a:rPr lang="en-US" sz="1400" b="1" dirty="0">
+          <a:p>
+            <a:pPr indent="0" marL="0">
+              <a:spcAft>
+                <a:spcPts val="400"/>
+              </a:spcAft>
+              <a:buNone/>
+            </a:pPr>
+            <a:r>
+              <a:rPr lang="en-US" sz="1200" b="1" dirty="0">
                 <a:solidFill>
                   <a:schemeClr val="tx1"/>
                 </a:solidFill>
               </a:rPr>
-              <a:t>Pipeline runs</a:t>
-            </a:r>
-            <a:endParaRPr lang="en-US" sz="1400" dirty="0"/>
-          </a:p>
-        </p:txBody>
-      </p:sp>
-      <p:sp>
-        <p:nvSpPr>
-          <p:cNvPr id="16" name="Text 14"/>
-          <p:cNvSpPr txBox="1"/>
-          <p:nvPr/>
-        </p:nvSpPr>
-        <p:spPr>
-          <a:xfrm>
-            <a:off x="3785616" y="2788920"/>
-            <a:ext cx="1554480" cy="640080"/>
-          </a:xfrm>
-          <a:prstGeom prst="rect">
-            <a:avLst/>
-          </a:prstGeom>
-          <a:noFill/>
-          <a:ln/>
-        </p:spPr>
-        <p:txBody>
-          <a:bodyPr wrap="square" lIns="0" tIns="0" rIns="0" bIns="0" rtlCol="0" anchor="t"/>
-          <a:lstStyle/>
-          <a:p>
-            <a:pPr algn="ctr" indent="0" marL="0">
+              <a:t>Fix: </a:t>
+            </a:r>
+            <a:pPr indent="0" marL="0">
+              <a:spcAft>
+                <a:spcPts val="400"/>
+              </a:spcAft>
               <a:buNone/>
             </a:pPr>
             <a:r>
               <a:rPr lang="en-US" sz="1200" dirty="0">
                 <a:solidFill>
-                  <a:schemeClr val="accent6"/>
-                </a:solidFill>
-              </a:rPr>
-              <a:t>tests, build, Trivy, push</a:t>
+                  <a:schemeClr val="tx1"/>
+                </a:solidFill>
+              </a:rPr>
+              <a:t>Patch the selector to match</a:t>
             </a:r>
             <a:endParaRPr lang="en-US" sz="1200" dirty="0"/>
-          </a:p>
-        </p:txBody>
-      </p:sp>
-      <p:sp>
-        <p:nvSpPr>
-          <p:cNvPr id="17" name="Demo step 4"/>
-          <p:cNvSpPr/>
-          <p:nvPr/>
-        </p:nvSpPr>
-        <p:spPr>
-          <a:xfrm>
-            <a:off x="5952744" y="1325880"/>
-            <a:ext cx="548640" cy="548640"/>
-          </a:xfrm>
-          <a:prstGeom prst="ellipse">
-            <a:avLst/>
-          </a:prstGeom>
-          <a:solidFill>
-            <a:schemeClr val="accent1"/>
-          </a:solidFill>
-          <a:ln/>
-        </p:spPr>
-      </p:sp>
-      <p:sp>
-        <p:nvSpPr>
-          <p:cNvPr id="18" name="Text 16"/>
-          <p:cNvSpPr txBox="1"/>
-          <p:nvPr/>
-        </p:nvSpPr>
-        <p:spPr>
-          <a:xfrm>
-            <a:off x="5952744" y="1325880"/>
-            <a:ext cx="548640" cy="548640"/>
-          </a:xfrm>
-          <a:prstGeom prst="rect">
-            <a:avLst/>
-          </a:prstGeom>
-          <a:noFill/>
-          <a:ln/>
-        </p:spPr>
-        <p:txBody>
-          <a:bodyPr wrap="square" lIns="0" tIns="0" rIns="0" bIns="0" rtlCol="0" anchor="ctr"/>
-          <a:lstStyle/>
-          <a:p>
-            <a:pPr algn="ctr" indent="0" marL="0">
-              <a:buNone/>
-            </a:pPr>
-            <a:r>
-              <a:rPr lang="en-US" sz="2000" b="1" dirty="0">
-                <a:solidFill>
-                  <a:schemeClr val="bg1"/>
-                </a:solidFill>
-              </a:rPr>
-              <a:t>4</a:t>
-            </a:r>
-            <a:endParaRPr lang="en-US" sz="2000" dirty="0"/>
-          </a:p>
-        </p:txBody>
-      </p:sp>
-      <p:sp>
-        <p:nvSpPr>
-          <p:cNvPr id="19" name="Text 17"/>
-          <p:cNvSpPr txBox="1"/>
-          <p:nvPr/>
-        </p:nvSpPr>
-        <p:spPr>
-          <a:xfrm>
-            <a:off x="5449824" y="2057400"/>
-            <a:ext cx="1554480" cy="731520"/>
-          </a:xfrm>
-          <a:prstGeom prst="rect">
-            <a:avLst/>
-          </a:prstGeom>
-          <a:noFill/>
-          <a:ln/>
-        </p:spPr>
-        <p:txBody>
-          <a:bodyPr wrap="square" lIns="0" tIns="0" rIns="0" bIns="0" rtlCol="0" anchor="t"/>
-          <a:lstStyle/>
-          <a:p>
-            <a:pPr algn="ctr" indent="0" marL="0">
-              <a:buNone/>
-            </a:pPr>
-            <a:r>
-              <a:rPr lang="en-US" sz="1400" b="1" dirty="0">
-                <a:solidFill>
-                  <a:schemeClr val="tx1"/>
-                </a:solidFill>
-              </a:rPr>
-              <a:t>scripts/deploy.sh &lt;sha&gt;</a:t>
-            </a:r>
-            <a:endParaRPr lang="en-US" sz="1400" dirty="0"/>
-          </a:p>
-        </p:txBody>
-      </p:sp>
-      <p:sp>
-        <p:nvSpPr>
-          <p:cNvPr id="20" name="Text 18"/>
-          <p:cNvSpPr txBox="1"/>
-          <p:nvPr/>
-        </p:nvSpPr>
-        <p:spPr>
-          <a:xfrm>
-            <a:off x="5449824" y="2788920"/>
-            <a:ext cx="1554480" cy="640080"/>
-          </a:xfrm>
-          <a:prstGeom prst="rect">
-            <a:avLst/>
-          </a:prstGeom>
-          <a:noFill/>
-          <a:ln/>
-        </p:spPr>
-        <p:txBody>
-          <a:bodyPr wrap="square" lIns="0" tIns="0" rIns="0" bIns="0" rtlCol="0" anchor="t"/>
-          <a:lstStyle/>
-          <a:p>
-            <a:pPr algn="ctr" indent="0" marL="0">
-              <a:buNone/>
-            </a:pPr>
-            <a:r>
-              <a:rPr lang="en-US" sz="1200" dirty="0">
-                <a:solidFill>
-                  <a:schemeClr val="accent6"/>
-                </a:solidFill>
-              </a:rPr>
-              <a:t>helm upgrade</a:t>
-            </a:r>
-            <a:endParaRPr lang="en-US" sz="1200" dirty="0"/>
-          </a:p>
-        </p:txBody>
-      </p:sp>
-      <p:sp>
-        <p:nvSpPr>
-          <p:cNvPr id="21" name="Demo step 5"/>
-          <p:cNvSpPr/>
-          <p:nvPr/>
-        </p:nvSpPr>
-        <p:spPr>
-          <a:xfrm>
-            <a:off x="7616952" y="1325880"/>
-            <a:ext cx="548640" cy="548640"/>
-          </a:xfrm>
-          <a:prstGeom prst="ellipse">
-            <a:avLst/>
-          </a:prstGeom>
-          <a:solidFill>
-            <a:schemeClr val="accent1"/>
-          </a:solidFill>
-          <a:ln/>
-        </p:spPr>
-      </p:sp>
-      <p:sp>
-        <p:nvSpPr>
-          <p:cNvPr id="22" name="Text 20"/>
-          <p:cNvSpPr txBox="1"/>
-          <p:nvPr/>
-        </p:nvSpPr>
-        <p:spPr>
-          <a:xfrm>
-            <a:off x="7616952" y="1325880"/>
-            <a:ext cx="548640" cy="548640"/>
-          </a:xfrm>
-          <a:prstGeom prst="rect">
-            <a:avLst/>
-          </a:prstGeom>
-          <a:noFill/>
-          <a:ln/>
-        </p:spPr>
-        <p:txBody>
-          <a:bodyPr wrap="square" lIns="0" tIns="0" rIns="0" bIns="0" rtlCol="0" anchor="ctr"/>
-          <a:lstStyle/>
-          <a:p>
-            <a:pPr algn="ctr" indent="0" marL="0">
-              <a:buNone/>
-            </a:pPr>
-            <a:r>
-              <a:rPr lang="en-US" sz="2000" b="1" dirty="0">
-                <a:solidFill>
-                  <a:schemeClr val="bg1"/>
-                </a:solidFill>
-              </a:rPr>
-              <a:t>5</a:t>
-            </a:r>
-            <a:endParaRPr lang="en-US" sz="2000" dirty="0"/>
-          </a:p>
-        </p:txBody>
-      </p:sp>
-      <p:sp>
-        <p:nvSpPr>
-          <p:cNvPr id="23" name="Text 21"/>
-          <p:cNvSpPr txBox="1"/>
-          <p:nvPr/>
-        </p:nvSpPr>
-        <p:spPr>
-          <a:xfrm>
-            <a:off x="7114032" y="2057400"/>
-            <a:ext cx="1554480" cy="731520"/>
-          </a:xfrm>
-          <a:prstGeom prst="rect">
-            <a:avLst/>
-          </a:prstGeom>
-          <a:noFill/>
-          <a:ln/>
-        </p:spPr>
-        <p:txBody>
-          <a:bodyPr wrap="square" lIns="0" tIns="0" rIns="0" bIns="0" rtlCol="0" anchor="t"/>
-          <a:lstStyle/>
-          <a:p>
-            <a:pPr algn="ctr" indent="0" marL="0">
-              <a:buNone/>
-            </a:pPr>
-            <a:r>
-              <a:rPr lang="en-US" sz="1400" b="1" dirty="0">
-                <a:solidFill>
-                  <a:schemeClr val="tx1"/>
-                </a:solidFill>
-              </a:rPr>
-              <a:t>Refresh the browser</a:t>
-            </a:r>
-            <a:endParaRPr lang="en-US" sz="1400" dirty="0"/>
-          </a:p>
-        </p:txBody>
-      </p:sp>
-      <p:sp>
-        <p:nvSpPr>
-          <p:cNvPr id="24" name="Text 22"/>
-          <p:cNvSpPr txBox="1"/>
-          <p:nvPr/>
-        </p:nvSpPr>
-        <p:spPr>
-          <a:xfrm>
-            <a:off x="7114032" y="2788920"/>
-            <a:ext cx="1554480" cy="640080"/>
-          </a:xfrm>
-          <a:prstGeom prst="rect">
-            <a:avLst/>
-          </a:prstGeom>
-          <a:noFill/>
-          <a:ln/>
-        </p:spPr>
-        <p:txBody>
-          <a:bodyPr wrap="square" lIns="0" tIns="0" rIns="0" bIns="0" rtlCol="0" anchor="t"/>
-          <a:lstStyle/>
-          <a:p>
-            <a:pPr algn="ctr" indent="0" marL="0">
-              <a:buNone/>
-            </a:pPr>
-            <a:r>
-              <a:rPr lang="en-US" sz="1200" dirty="0">
-                <a:solidFill>
-                  <a:schemeClr val="accent6"/>
-                </a:solidFill>
-              </a:rPr>
-              <a:t>new text is live</a:t>
-            </a:r>
-            <a:endParaRPr lang="en-US" sz="1200" dirty="0"/>
-          </a:p>
-        </p:txBody>
-      </p:sp>
-      <p:sp>
-        <p:nvSpPr>
-          <p:cNvPr id="25" name="Text 23"/>
-          <p:cNvSpPr txBox="1"/>
-          <p:nvPr/>
-        </p:nvSpPr>
-        <p:spPr>
-          <a:xfrm>
-            <a:off x="457200" y="3840480"/>
-            <a:ext cx="8229600" cy="457200"/>
-          </a:xfrm>
-          <a:prstGeom prst="rect">
-            <a:avLst/>
-          </a:prstGeom>
-          <a:noFill/>
-          <a:ln/>
-        </p:spPr>
-        <p:txBody>
-          <a:bodyPr wrap="square" lIns="0" tIns="0" rIns="0" bIns="0" rtlCol="0" anchor="ctr"/>
-          <a:lstStyle/>
-          <a:p>
-            <a:pPr indent="0" marL="0">
-              <a:buNone/>
-            </a:pPr>
-            <a:r>
-              <a:rPr lang="en-US" sz="1600" i="1" dirty="0">
-                <a:solidFill>
-                  <a:schemeClr val="accent1"/>
-                </a:solidFill>
-              </a:rPr>
-              <a:t>Commit a change, watch the pipeline run, see the deployment update.</a:t>
-            </a:r>
-            <a:endParaRPr lang="en-US" sz="1600" dirty="0"/>
           </a:p>
         </p:txBody>
       </p:sp>
@@ -5034,6 +4640,848 @@
       </p:grpSpPr>
       <p:sp>
         <p:nvSpPr>
+          <p:cNvPr id="2" name="Text 1"/>
+          <p:cNvSpPr/>
+          <p:nvPr>
+            <p:ph idx="101" type="title" hasCustomPrompt="1"/>
+          </p:nvPr>
+        </p:nvSpPr>
+        <p:spPr>
+          <a:xfrm>
+            <a:off x="1280160" y="365760"/>
+            <a:ext cx="7406640" cy="566928"/>
+          </a:xfrm>
+          <a:prstGeom prst="rect">
+            <a:avLst/>
+          </a:prstGeom>
+          <a:noFill/>
+          <a:ln/>
+        </p:spPr>
+        <p:txBody>
+          <a:bodyPr wrap="square" lIns="0" tIns="0" rIns="0" bIns="0" rtlCol="0" anchor="ctr"/>
+          <a:lstStyle/>
+          <a:p>
+            <a:pPr algn="l" indent="0" marL="0">
+              <a:buNone/>
+            </a:pPr>
+            <a:r>
+              <a:rPr lang="en-US" sz="3200" b="1" dirty="0">
+                <a:solidFill>
+                  <a:schemeClr val="tx1"/>
+                </a:solidFill>
+              </a:rPr>
+              <a:t>Live demo flow</a:t>
+            </a:r>
+            <a:endParaRPr lang="en-US" sz="3200" dirty="0"/>
+          </a:p>
+        </p:txBody>
+      </p:sp>
+      <p:sp>
+        <p:nvSpPr>
+          <p:cNvPr id="3" name="Module chip"/>
+          <p:cNvSpPr/>
+          <p:nvPr/>
+        </p:nvSpPr>
+        <p:spPr>
+          <a:xfrm>
+            <a:off x="457200" y="420624"/>
+            <a:ext cx="777240" cy="457200"/>
+          </a:xfrm>
+          <a:prstGeom prst="roundRect">
+            <a:avLst>
+              <a:gd name="adj" fmla="val 20000"/>
+            </a:avLst>
+          </a:prstGeom>
+          <a:solidFill>
+            <a:schemeClr val="accent1"/>
+          </a:solidFill>
+          <a:ln/>
+        </p:spPr>
+      </p:sp>
+      <p:sp>
+        <p:nvSpPr>
+          <p:cNvPr id="4" name="Text 2"/>
+          <p:cNvSpPr txBox="1"/>
+          <p:nvPr/>
+        </p:nvSpPr>
+        <p:spPr>
+          <a:xfrm>
+            <a:off x="457200" y="420624"/>
+            <a:ext cx="777240" cy="457200"/>
+          </a:xfrm>
+          <a:prstGeom prst="rect">
+            <a:avLst/>
+          </a:prstGeom>
+          <a:noFill/>
+          <a:ln/>
+        </p:spPr>
+        <p:txBody>
+          <a:bodyPr wrap="square" lIns="0" tIns="0" rIns="0" bIns="0" rtlCol="0" anchor="ctr"/>
+          <a:lstStyle/>
+          <a:p>
+            <a:pPr algn="ctr" indent="0" marL="0">
+              <a:buNone/>
+            </a:pPr>
+            <a:r>
+              <a:rPr lang="en-US" sz="1400" b="1" dirty="0">
+                <a:solidFill>
+                  <a:schemeClr val="bg1"/>
+                </a:solidFill>
+              </a:rPr>
+              <a:t>DEMO</a:t>
+            </a:r>
+            <a:endParaRPr lang="en-US" sz="1400" dirty="0"/>
+          </a:p>
+        </p:txBody>
+      </p:sp>
+      <p:sp>
+        <p:nvSpPr>
+          <p:cNvPr id="5" name="Demo step 1"/>
+          <p:cNvSpPr/>
+          <p:nvPr/>
+        </p:nvSpPr>
+        <p:spPr>
+          <a:xfrm>
+            <a:off x="960120" y="1325880"/>
+            <a:ext cx="548640" cy="548640"/>
+          </a:xfrm>
+          <a:prstGeom prst="ellipse">
+            <a:avLst/>
+          </a:prstGeom>
+          <a:solidFill>
+            <a:schemeClr val="accent1"/>
+          </a:solidFill>
+          <a:ln/>
+        </p:spPr>
+      </p:sp>
+      <p:sp>
+        <p:nvSpPr>
+          <p:cNvPr id="6" name="Text 4"/>
+          <p:cNvSpPr txBox="1"/>
+          <p:nvPr/>
+        </p:nvSpPr>
+        <p:spPr>
+          <a:xfrm>
+            <a:off x="960120" y="1325880"/>
+            <a:ext cx="548640" cy="548640"/>
+          </a:xfrm>
+          <a:prstGeom prst="rect">
+            <a:avLst/>
+          </a:prstGeom>
+          <a:noFill/>
+          <a:ln/>
+        </p:spPr>
+        <p:txBody>
+          <a:bodyPr wrap="square" lIns="0" tIns="0" rIns="0" bIns="0" rtlCol="0" anchor="ctr"/>
+          <a:lstStyle/>
+          <a:p>
+            <a:pPr algn="ctr" indent="0" marL="0">
+              <a:buNone/>
+            </a:pPr>
+            <a:r>
+              <a:rPr lang="en-US" sz="2000" b="1" dirty="0">
+                <a:solidFill>
+                  <a:schemeClr val="bg1"/>
+                </a:solidFill>
+              </a:rPr>
+              <a:t>1</a:t>
+            </a:r>
+            <a:endParaRPr lang="en-US" sz="2000" dirty="0"/>
+          </a:p>
+        </p:txBody>
+      </p:sp>
+      <p:sp>
+        <p:nvSpPr>
+          <p:cNvPr id="7" name="Text 5"/>
+          <p:cNvSpPr txBox="1"/>
+          <p:nvPr/>
+        </p:nvSpPr>
+        <p:spPr>
+          <a:xfrm>
+            <a:off x="457200" y="2057400"/>
+            <a:ext cx="1554480" cy="731520"/>
+          </a:xfrm>
+          <a:prstGeom prst="rect">
+            <a:avLst/>
+          </a:prstGeom>
+          <a:noFill/>
+          <a:ln/>
+        </p:spPr>
+        <p:txBody>
+          <a:bodyPr wrap="square" lIns="0" tIns="0" rIns="0" bIns="0" rtlCol="0" anchor="t"/>
+          <a:lstStyle/>
+          <a:p>
+            <a:pPr algn="ctr" indent="0" marL="0">
+              <a:buNone/>
+            </a:pPr>
+            <a:r>
+              <a:rPr lang="en-US" sz="1400" b="1" dirty="0">
+                <a:solidFill>
+                  <a:schemeClr val="tx1"/>
+                </a:solidFill>
+              </a:rPr>
+              <a:t>Edit a visible string</a:t>
+            </a:r>
+            <a:endParaRPr lang="en-US" sz="1400" dirty="0"/>
+          </a:p>
+        </p:txBody>
+      </p:sp>
+      <p:sp>
+        <p:nvSpPr>
+          <p:cNvPr id="8" name="Text 6"/>
+          <p:cNvSpPr txBox="1"/>
+          <p:nvPr/>
+        </p:nvSpPr>
+        <p:spPr>
+          <a:xfrm>
+            <a:off x="457200" y="2788920"/>
+            <a:ext cx="1554480" cy="640080"/>
+          </a:xfrm>
+          <a:prstGeom prst="rect">
+            <a:avLst/>
+          </a:prstGeom>
+          <a:noFill/>
+          <a:ln/>
+        </p:spPr>
+        <p:txBody>
+          <a:bodyPr wrap="square" lIns="0" tIns="0" rIns="0" bIns="0" rtlCol="0" anchor="t"/>
+          <a:lstStyle/>
+          <a:p>
+            <a:pPr algn="ctr" indent="0" marL="0">
+              <a:buNone/>
+            </a:pPr>
+            <a:r>
+              <a:rPr lang="en-US" sz="1200" dirty="0">
+                <a:solidFill>
+                  <a:schemeClr val="accent6"/>
+                </a:solidFill>
+              </a:rPr>
+              <a:t>frontend/src/App.jsx</a:t>
+            </a:r>
+            <a:endParaRPr lang="en-US" sz="1200" dirty="0"/>
+          </a:p>
+        </p:txBody>
+      </p:sp>
+      <p:sp>
+        <p:nvSpPr>
+          <p:cNvPr id="9" name="Demo step 2"/>
+          <p:cNvSpPr/>
+          <p:nvPr/>
+        </p:nvSpPr>
+        <p:spPr>
+          <a:xfrm>
+            <a:off x="2624328" y="1325880"/>
+            <a:ext cx="548640" cy="548640"/>
+          </a:xfrm>
+          <a:prstGeom prst="ellipse">
+            <a:avLst/>
+          </a:prstGeom>
+          <a:solidFill>
+            <a:schemeClr val="accent1"/>
+          </a:solidFill>
+          <a:ln/>
+        </p:spPr>
+      </p:sp>
+      <p:sp>
+        <p:nvSpPr>
+          <p:cNvPr id="10" name="Text 8"/>
+          <p:cNvSpPr txBox="1"/>
+          <p:nvPr/>
+        </p:nvSpPr>
+        <p:spPr>
+          <a:xfrm>
+            <a:off x="2624328" y="1325880"/>
+            <a:ext cx="548640" cy="548640"/>
+          </a:xfrm>
+          <a:prstGeom prst="rect">
+            <a:avLst/>
+          </a:prstGeom>
+          <a:noFill/>
+          <a:ln/>
+        </p:spPr>
+        <p:txBody>
+          <a:bodyPr wrap="square" lIns="0" tIns="0" rIns="0" bIns="0" rtlCol="0" anchor="ctr"/>
+          <a:lstStyle/>
+          <a:p>
+            <a:pPr algn="ctr" indent="0" marL="0">
+              <a:buNone/>
+            </a:pPr>
+            <a:r>
+              <a:rPr lang="en-US" sz="2000" b="1" dirty="0">
+                <a:solidFill>
+                  <a:schemeClr val="bg1"/>
+                </a:solidFill>
+              </a:rPr>
+              <a:t>2</a:t>
+            </a:r>
+            <a:endParaRPr lang="en-US" sz="2000" dirty="0"/>
+          </a:p>
+        </p:txBody>
+      </p:sp>
+      <p:sp>
+        <p:nvSpPr>
+          <p:cNvPr id="11" name="Text 9"/>
+          <p:cNvSpPr txBox="1"/>
+          <p:nvPr/>
+        </p:nvSpPr>
+        <p:spPr>
+          <a:xfrm>
+            <a:off x="2121408" y="2057400"/>
+            <a:ext cx="1554480" cy="731520"/>
+          </a:xfrm>
+          <a:prstGeom prst="rect">
+            <a:avLst/>
+          </a:prstGeom>
+          <a:noFill/>
+          <a:ln/>
+        </p:spPr>
+        <p:txBody>
+          <a:bodyPr wrap="square" lIns="0" tIns="0" rIns="0" bIns="0" rtlCol="0" anchor="t"/>
+          <a:lstStyle/>
+          <a:p>
+            <a:pPr algn="ctr" indent="0" marL="0">
+              <a:buNone/>
+            </a:pPr>
+            <a:r>
+              <a:rPr lang="en-US" sz="1400" b="1" dirty="0">
+                <a:solidFill>
+                  <a:schemeClr val="tx1"/>
+                </a:solidFill>
+              </a:rPr>
+              <a:t>git commit and push</a:t>
+            </a:r>
+            <a:endParaRPr lang="en-US" sz="1400" dirty="0"/>
+          </a:p>
+        </p:txBody>
+      </p:sp>
+      <p:sp>
+        <p:nvSpPr>
+          <p:cNvPr id="12" name="Text 10"/>
+          <p:cNvSpPr txBox="1"/>
+          <p:nvPr/>
+        </p:nvSpPr>
+        <p:spPr>
+          <a:xfrm>
+            <a:off x="2121408" y="2788920"/>
+            <a:ext cx="1554480" cy="640080"/>
+          </a:xfrm>
+          <a:prstGeom prst="rect">
+            <a:avLst/>
+          </a:prstGeom>
+          <a:noFill/>
+          <a:ln/>
+        </p:spPr>
+        <p:txBody>
+          <a:bodyPr wrap="square" lIns="0" tIns="0" rIns="0" bIns="0" rtlCol="0" anchor="t"/>
+          <a:lstStyle/>
+          <a:p>
+            <a:pPr algn="ctr" indent="0" marL="0">
+              <a:buNone/>
+            </a:pPr>
+            <a:r>
+              <a:rPr lang="en-US" sz="1200" dirty="0">
+                <a:solidFill>
+                  <a:schemeClr val="accent6"/>
+                </a:solidFill>
+              </a:rPr>
+              <a:t>triggers Actions</a:t>
+            </a:r>
+            <a:endParaRPr lang="en-US" sz="1200" dirty="0"/>
+          </a:p>
+        </p:txBody>
+      </p:sp>
+      <p:sp>
+        <p:nvSpPr>
+          <p:cNvPr id="13" name="Demo step 3"/>
+          <p:cNvSpPr/>
+          <p:nvPr/>
+        </p:nvSpPr>
+        <p:spPr>
+          <a:xfrm>
+            <a:off x="4288536" y="1325880"/>
+            <a:ext cx="548640" cy="548640"/>
+          </a:xfrm>
+          <a:prstGeom prst="ellipse">
+            <a:avLst/>
+          </a:prstGeom>
+          <a:solidFill>
+            <a:schemeClr val="accent1"/>
+          </a:solidFill>
+          <a:ln/>
+        </p:spPr>
+      </p:sp>
+      <p:sp>
+        <p:nvSpPr>
+          <p:cNvPr id="14" name="Text 12"/>
+          <p:cNvSpPr txBox="1"/>
+          <p:nvPr/>
+        </p:nvSpPr>
+        <p:spPr>
+          <a:xfrm>
+            <a:off x="4288536" y="1325880"/>
+            <a:ext cx="548640" cy="548640"/>
+          </a:xfrm>
+          <a:prstGeom prst="rect">
+            <a:avLst/>
+          </a:prstGeom>
+          <a:noFill/>
+          <a:ln/>
+        </p:spPr>
+        <p:txBody>
+          <a:bodyPr wrap="square" lIns="0" tIns="0" rIns="0" bIns="0" rtlCol="0" anchor="ctr"/>
+          <a:lstStyle/>
+          <a:p>
+            <a:pPr algn="ctr" indent="0" marL="0">
+              <a:buNone/>
+            </a:pPr>
+            <a:r>
+              <a:rPr lang="en-US" sz="2000" b="1" dirty="0">
+                <a:solidFill>
+                  <a:schemeClr val="bg1"/>
+                </a:solidFill>
+              </a:rPr>
+              <a:t>3</a:t>
+            </a:r>
+            <a:endParaRPr lang="en-US" sz="2000" dirty="0"/>
+          </a:p>
+        </p:txBody>
+      </p:sp>
+      <p:sp>
+        <p:nvSpPr>
+          <p:cNvPr id="15" name="Text 13"/>
+          <p:cNvSpPr txBox="1"/>
+          <p:nvPr/>
+        </p:nvSpPr>
+        <p:spPr>
+          <a:xfrm>
+            <a:off x="3785616" y="2057400"/>
+            <a:ext cx="1554480" cy="731520"/>
+          </a:xfrm>
+          <a:prstGeom prst="rect">
+            <a:avLst/>
+          </a:prstGeom>
+          <a:noFill/>
+          <a:ln/>
+        </p:spPr>
+        <p:txBody>
+          <a:bodyPr wrap="square" lIns="0" tIns="0" rIns="0" bIns="0" rtlCol="0" anchor="t"/>
+          <a:lstStyle/>
+          <a:p>
+            <a:pPr algn="ctr" indent="0" marL="0">
+              <a:buNone/>
+            </a:pPr>
+            <a:r>
+              <a:rPr lang="en-US" sz="1400" b="1" dirty="0">
+                <a:solidFill>
+                  <a:schemeClr val="tx1"/>
+                </a:solidFill>
+              </a:rPr>
+              <a:t>Pipeline runs</a:t>
+            </a:r>
+            <a:endParaRPr lang="en-US" sz="1400" dirty="0"/>
+          </a:p>
+        </p:txBody>
+      </p:sp>
+      <p:sp>
+        <p:nvSpPr>
+          <p:cNvPr id="16" name="Text 14"/>
+          <p:cNvSpPr txBox="1"/>
+          <p:nvPr/>
+        </p:nvSpPr>
+        <p:spPr>
+          <a:xfrm>
+            <a:off x="3785616" y="2788920"/>
+            <a:ext cx="1554480" cy="640080"/>
+          </a:xfrm>
+          <a:prstGeom prst="rect">
+            <a:avLst/>
+          </a:prstGeom>
+          <a:noFill/>
+          <a:ln/>
+        </p:spPr>
+        <p:txBody>
+          <a:bodyPr wrap="square" lIns="0" tIns="0" rIns="0" bIns="0" rtlCol="0" anchor="t"/>
+          <a:lstStyle/>
+          <a:p>
+            <a:pPr algn="ctr" indent="0" marL="0">
+              <a:buNone/>
+            </a:pPr>
+            <a:r>
+              <a:rPr lang="en-US" sz="1200" dirty="0">
+                <a:solidFill>
+                  <a:schemeClr val="accent6"/>
+                </a:solidFill>
+              </a:rPr>
+              <a:t>tests, build, Trivy, push</a:t>
+            </a:r>
+            <a:endParaRPr lang="en-US" sz="1200" dirty="0"/>
+          </a:p>
+        </p:txBody>
+      </p:sp>
+      <p:sp>
+        <p:nvSpPr>
+          <p:cNvPr id="17" name="Demo step 4"/>
+          <p:cNvSpPr/>
+          <p:nvPr/>
+        </p:nvSpPr>
+        <p:spPr>
+          <a:xfrm>
+            <a:off x="5952744" y="1325880"/>
+            <a:ext cx="548640" cy="548640"/>
+          </a:xfrm>
+          <a:prstGeom prst="ellipse">
+            <a:avLst/>
+          </a:prstGeom>
+          <a:solidFill>
+            <a:schemeClr val="accent1"/>
+          </a:solidFill>
+          <a:ln/>
+        </p:spPr>
+      </p:sp>
+      <p:sp>
+        <p:nvSpPr>
+          <p:cNvPr id="18" name="Text 16"/>
+          <p:cNvSpPr txBox="1"/>
+          <p:nvPr/>
+        </p:nvSpPr>
+        <p:spPr>
+          <a:xfrm>
+            <a:off x="5952744" y="1325880"/>
+            <a:ext cx="548640" cy="548640"/>
+          </a:xfrm>
+          <a:prstGeom prst="rect">
+            <a:avLst/>
+          </a:prstGeom>
+          <a:noFill/>
+          <a:ln/>
+        </p:spPr>
+        <p:txBody>
+          <a:bodyPr wrap="square" lIns="0" tIns="0" rIns="0" bIns="0" rtlCol="0" anchor="ctr"/>
+          <a:lstStyle/>
+          <a:p>
+            <a:pPr algn="ctr" indent="0" marL="0">
+              <a:buNone/>
+            </a:pPr>
+            <a:r>
+              <a:rPr lang="en-US" sz="2000" b="1" dirty="0">
+                <a:solidFill>
+                  <a:schemeClr val="bg1"/>
+                </a:solidFill>
+              </a:rPr>
+              <a:t>4</a:t>
+            </a:r>
+            <a:endParaRPr lang="en-US" sz="2000" dirty="0"/>
+          </a:p>
+        </p:txBody>
+      </p:sp>
+      <p:sp>
+        <p:nvSpPr>
+          <p:cNvPr id="19" name="Text 17"/>
+          <p:cNvSpPr txBox="1"/>
+          <p:nvPr/>
+        </p:nvSpPr>
+        <p:spPr>
+          <a:xfrm>
+            <a:off x="5449824" y="2057400"/>
+            <a:ext cx="1554480" cy="731520"/>
+          </a:xfrm>
+          <a:prstGeom prst="rect">
+            <a:avLst/>
+          </a:prstGeom>
+          <a:noFill/>
+          <a:ln/>
+        </p:spPr>
+        <p:txBody>
+          <a:bodyPr wrap="square" lIns="0" tIns="0" rIns="0" bIns="0" rtlCol="0" anchor="t"/>
+          <a:lstStyle/>
+          <a:p>
+            <a:pPr algn="ctr" indent="0" marL="0">
+              <a:buNone/>
+            </a:pPr>
+            <a:r>
+              <a:rPr lang="en-US" sz="1400" b="1" dirty="0">
+                <a:solidFill>
+                  <a:schemeClr val="tx1"/>
+                </a:solidFill>
+              </a:rPr>
+              <a:t>scripts/deploy.sh &lt;sha&gt;</a:t>
+            </a:r>
+            <a:endParaRPr lang="en-US" sz="1400" dirty="0"/>
+          </a:p>
+        </p:txBody>
+      </p:sp>
+      <p:sp>
+        <p:nvSpPr>
+          <p:cNvPr id="20" name="Text 18"/>
+          <p:cNvSpPr txBox="1"/>
+          <p:nvPr/>
+        </p:nvSpPr>
+        <p:spPr>
+          <a:xfrm>
+            <a:off x="5449824" y="2788920"/>
+            <a:ext cx="1554480" cy="640080"/>
+          </a:xfrm>
+          <a:prstGeom prst="rect">
+            <a:avLst/>
+          </a:prstGeom>
+          <a:noFill/>
+          <a:ln/>
+        </p:spPr>
+        <p:txBody>
+          <a:bodyPr wrap="square" lIns="0" tIns="0" rIns="0" bIns="0" rtlCol="0" anchor="t"/>
+          <a:lstStyle/>
+          <a:p>
+            <a:pPr algn="ctr" indent="0" marL="0">
+              <a:buNone/>
+            </a:pPr>
+            <a:r>
+              <a:rPr lang="en-US" sz="1200" dirty="0">
+                <a:solidFill>
+                  <a:schemeClr val="accent6"/>
+                </a:solidFill>
+              </a:rPr>
+              <a:t>helm upgrade</a:t>
+            </a:r>
+            <a:endParaRPr lang="en-US" sz="1200" dirty="0"/>
+          </a:p>
+        </p:txBody>
+      </p:sp>
+      <p:sp>
+        <p:nvSpPr>
+          <p:cNvPr id="21" name="Demo step 5"/>
+          <p:cNvSpPr/>
+          <p:nvPr/>
+        </p:nvSpPr>
+        <p:spPr>
+          <a:xfrm>
+            <a:off x="7616952" y="1325880"/>
+            <a:ext cx="548640" cy="548640"/>
+          </a:xfrm>
+          <a:prstGeom prst="ellipse">
+            <a:avLst/>
+          </a:prstGeom>
+          <a:solidFill>
+            <a:schemeClr val="accent1"/>
+          </a:solidFill>
+          <a:ln/>
+        </p:spPr>
+      </p:sp>
+      <p:sp>
+        <p:nvSpPr>
+          <p:cNvPr id="22" name="Text 20"/>
+          <p:cNvSpPr txBox="1"/>
+          <p:nvPr/>
+        </p:nvSpPr>
+        <p:spPr>
+          <a:xfrm>
+            <a:off x="7616952" y="1325880"/>
+            <a:ext cx="548640" cy="548640"/>
+          </a:xfrm>
+          <a:prstGeom prst="rect">
+            <a:avLst/>
+          </a:prstGeom>
+          <a:noFill/>
+          <a:ln/>
+        </p:spPr>
+        <p:txBody>
+          <a:bodyPr wrap="square" lIns="0" tIns="0" rIns="0" bIns="0" rtlCol="0" anchor="ctr"/>
+          <a:lstStyle/>
+          <a:p>
+            <a:pPr algn="ctr" indent="0" marL="0">
+              <a:buNone/>
+            </a:pPr>
+            <a:r>
+              <a:rPr lang="en-US" sz="2000" b="1" dirty="0">
+                <a:solidFill>
+                  <a:schemeClr val="bg1"/>
+                </a:solidFill>
+              </a:rPr>
+              <a:t>5</a:t>
+            </a:r>
+            <a:endParaRPr lang="en-US" sz="2000" dirty="0"/>
+          </a:p>
+        </p:txBody>
+      </p:sp>
+      <p:sp>
+        <p:nvSpPr>
+          <p:cNvPr id="23" name="Text 21"/>
+          <p:cNvSpPr txBox="1"/>
+          <p:nvPr/>
+        </p:nvSpPr>
+        <p:spPr>
+          <a:xfrm>
+            <a:off x="7114032" y="2057400"/>
+            <a:ext cx="1554480" cy="731520"/>
+          </a:xfrm>
+          <a:prstGeom prst="rect">
+            <a:avLst/>
+          </a:prstGeom>
+          <a:noFill/>
+          <a:ln/>
+        </p:spPr>
+        <p:txBody>
+          <a:bodyPr wrap="square" lIns="0" tIns="0" rIns="0" bIns="0" rtlCol="0" anchor="t"/>
+          <a:lstStyle/>
+          <a:p>
+            <a:pPr algn="ctr" indent="0" marL="0">
+              <a:buNone/>
+            </a:pPr>
+            <a:r>
+              <a:rPr lang="en-US" sz="1400" b="1" dirty="0">
+                <a:solidFill>
+                  <a:schemeClr val="tx1"/>
+                </a:solidFill>
+              </a:rPr>
+              <a:t>Refresh the browser</a:t>
+            </a:r>
+            <a:endParaRPr lang="en-US" sz="1400" dirty="0"/>
+          </a:p>
+        </p:txBody>
+      </p:sp>
+      <p:sp>
+        <p:nvSpPr>
+          <p:cNvPr id="24" name="Text 22"/>
+          <p:cNvSpPr txBox="1"/>
+          <p:nvPr/>
+        </p:nvSpPr>
+        <p:spPr>
+          <a:xfrm>
+            <a:off x="7114032" y="2788920"/>
+            <a:ext cx="1554480" cy="640080"/>
+          </a:xfrm>
+          <a:prstGeom prst="rect">
+            <a:avLst/>
+          </a:prstGeom>
+          <a:noFill/>
+          <a:ln/>
+        </p:spPr>
+        <p:txBody>
+          <a:bodyPr wrap="square" lIns="0" tIns="0" rIns="0" bIns="0" rtlCol="0" anchor="t"/>
+          <a:lstStyle/>
+          <a:p>
+            <a:pPr algn="ctr" indent="0" marL="0">
+              <a:buNone/>
+            </a:pPr>
+            <a:r>
+              <a:rPr lang="en-US" sz="1200" dirty="0">
+                <a:solidFill>
+                  <a:schemeClr val="accent6"/>
+                </a:solidFill>
+              </a:rPr>
+              <a:t>new text is live</a:t>
+            </a:r>
+            <a:endParaRPr lang="en-US" sz="1200" dirty="0"/>
+          </a:p>
+        </p:txBody>
+      </p:sp>
+      <p:sp>
+        <p:nvSpPr>
+          <p:cNvPr id="25" name="Text 23"/>
+          <p:cNvSpPr txBox="1"/>
+          <p:nvPr/>
+        </p:nvSpPr>
+        <p:spPr>
+          <a:xfrm>
+            <a:off x="457200" y="3840480"/>
+            <a:ext cx="8229600" cy="457200"/>
+          </a:xfrm>
+          <a:prstGeom prst="rect">
+            <a:avLst/>
+          </a:prstGeom>
+          <a:noFill/>
+          <a:ln/>
+        </p:spPr>
+        <p:txBody>
+          <a:bodyPr wrap="square" lIns="0" tIns="0" rIns="0" bIns="0" rtlCol="0" anchor="ctr"/>
+          <a:lstStyle/>
+          <a:p>
+            <a:pPr indent="0" marL="0">
+              <a:buNone/>
+            </a:pPr>
+            <a:r>
+              <a:rPr lang="en-US" sz="1600" i="1" dirty="0">
+                <a:solidFill>
+                  <a:schemeClr val="accent1"/>
+                </a:solidFill>
+              </a:rPr>
+              <a:t>Commit a change, watch the pipeline run, see the deployment update.</a:t>
+            </a:r>
+            <a:endParaRPr lang="en-US" sz="1600" dirty="0"/>
+          </a:p>
+        </p:txBody>
+      </p:sp>
+      <p:sp>
+        <p:nvSpPr>
+          <p:cNvPr id="25" name="Slide Number Placeholder 0"/>
+          <p:cNvSpPr>
+            <a:spLocks noGrp="1"/>
+          </p:cNvSpPr>
+          <p:nvPr>
+            <p:ph type="sldNum" sz="quarter" idx="4294967295"/>
+          </p:nvPr>
+        </p:nvSpPr>
+        <p:spPr>
+          <a:xfrm>
+            <a:off x="8229600" y="4773168"/>
+            <a:ext cx="457200" cy="274320"/>
+          </a:xfrm>
+          <a:prstGeom prst="rect">
+            <a:avLst/>
+          </a:prstGeom>
+          <a:extLst>
+            <a:ext uri="{C572A759-6A51-4108-AA02-DFA0A04FC94B}">
+              <ma14:wrappingTextBoxFlag xmlns:ma14="http://schemas.microsoft.com/office/mac/drawingml/2011/main" val="0"/>
+            </a:ext>
+          </a:extLst>
+        </p:spPr>
+        <p:txBody>
+          <a:bodyPr/>
+          <a:lstStyle>
+            <a:lvl1pPr>
+              <a:defRPr sz="1000">
+                <a:solidFill>
+                  <a:schemeClr val="accent6"/>
+                </a:solidFill>
+              </a:defRPr>
+            </a:lvl1pPr>
+          </a:lstStyle>
+          <a:p>
+            <a:pPr algn="l"/>
+            <a:fld id="{F7021451-1387-4CA6-816F-3879F97B5CBC}" type="slidenum">
+              <a:rPr b="0" lang="en-US"/>
+              <a:t>15</a:t>
+            </a:fld>
+            <a:endParaRPr lang="en-US"/>
+          </a:p>
+        </p:txBody>
+      </p:sp>
+    </p:spTree>
+  </p:cSld>
+  <p:clrMapOvr>
+    <a:masterClrMapping/>
+  </p:clrMapOvr>
+</p:sld>
+</file>
+
+<file path=ppt/slides/slide16.xml><?xml version="1.0" encoding="utf-8"?>
+<p:sld xmlns:a="http://schemas.openxmlformats.org/drawingml/2006/main" xmlns:r="http://schemas.openxmlformats.org/officeDocument/2006/relationships" xmlns:p="http://schemas.openxmlformats.org/presentationml/2006/main">
+  <p:cSld name="Slide 16">
+    <p:spTree>
+      <p:nvGrpSpPr>
+        <p:cNvPr id="1" name=""/>
+        <p:cNvGrpSpPr/>
+        <p:nvPr/>
+      </p:nvGrpSpPr>
+      <p:grpSpPr>
+        <a:xfrm>
+          <a:off x="0" y="0"/>
+          <a:ext cx="0" cy="0"/>
+          <a:chOff x="0" y="0"/>
+          <a:chExt cx="0" cy="0"/>
+        </a:xfrm>
+      </p:grpSpPr>
+      <p:sp>
+        <p:nvSpPr>
           <p:cNvPr id="2" name="Text 0"/>
           <p:cNvSpPr/>
           <p:nvPr>
@@ -7342,7 +7790,7 @@
                 <a:ea typeface="Cambria" pitchFamily="34" charset="-122"/>
                 <a:cs typeface="Cambria" pitchFamily="34" charset="-120"/>
               </a:rPr>
-              <a:t>24</a:t>
+              <a:t>27</a:t>
             </a:r>
             <a:endParaRPr lang="en-US" sz="4800" dirty="0"/>
           </a:p>
@@ -9196,8 +9644,8 @@
         </p:nvSpPr>
         <p:spPr>
           <a:xfrm>
-            <a:off x="457200" y="1188720"/>
-            <a:ext cx="3749040" cy="2651760"/>
+            <a:off x="457200" y="1097280"/>
+            <a:ext cx="8229600" cy="1097280"/>
           </a:xfrm>
           <a:prstGeom prst="rect">
             <a:avLst/>
@@ -9217,14 +9665,14 @@
               <a:buChar char="•"/>
             </a:pPr>
             <a:r>
-              <a:rPr lang="en-US" sz="1400" dirty="0">
+              <a:rPr lang="en-US" sz="1300" dirty="0">
                 <a:solidFill>
                   <a:schemeClr val="tx1"/>
                 </a:solidFill>
               </a:rPr>
               <a:t>VPC with 2 public subnets in 2 availability zones</a:t>
             </a:r>
-            <a:endParaRPr lang="en-US" sz="1400" dirty="0"/>
+            <a:endParaRPr lang="en-US" sz="1300" dirty="0"/>
           </a:p>
           <a:p>
             <a:pPr marL="342900" indent="-342900">
@@ -9235,14 +9683,14 @@
               <a:buChar char="•"/>
             </a:pPr>
             <a:r>
-              <a:rPr lang="en-US" sz="1400" dirty="0">
+              <a:rPr lang="en-US" sz="1300" dirty="0">
                 <a:solidFill>
                   <a:schemeClr val="tx1"/>
                 </a:solidFill>
               </a:rPr>
-              <a:t>EKS cluster + managed node group, 2 x t3.small</a:t>
-            </a:r>
-            <a:endParaRPr lang="en-US" sz="1400" dirty="0"/>
+              <a:t>EKS cluster + managed node group, 2 x t3.small, API limited to my IP</a:t>
+            </a:r>
+            <a:endParaRPr lang="en-US" sz="1300" dirty="0"/>
           </a:p>
           <a:p>
             <a:pPr marL="342900" indent="-342900">
@@ -9253,49 +9701,31 @@
               <a:buChar char="•"/>
             </a:pPr>
             <a:r>
-              <a:rPr lang="en-US" sz="1400" dirty="0">
+              <a:rPr lang="en-US" sz="1300" dirty="0">
                 <a:solidFill>
                   <a:schemeClr val="tx1"/>
                 </a:solidFill>
               </a:rPr>
-              <a:t>API endpoint limited to my IP; no secrets in code</a:t>
-            </a:r>
-            <a:endParaRPr lang="en-US" sz="1400" dirty="0"/>
-          </a:p>
-          <a:p>
-            <a:pPr marL="342900" indent="-342900">
-              <a:spcAft>
-                <a:spcPts val="800"/>
-              </a:spcAft>
-              <a:buSzPct val="100000"/>
-              <a:buChar char="•"/>
-            </a:pPr>
-            <a:r>
-              <a:rPr lang="en-US" sz="1400" dirty="0">
-                <a:solidFill>
-                  <a:schemeClr val="tx1"/>
-                </a:solidFill>
-              </a:rPr>
-              <a:t>plan: 53 to add, 0 to change, 0 to destroy</a:t>
-            </a:r>
-            <a:endParaRPr lang="en-US" sz="1400" dirty="0"/>
-          </a:p>
-        </p:txBody>
-      </p:sp>
-      <p:sp>
-        <p:nvSpPr>
-          <p:cNvPr id="6" name="terraform validate and plan output frame"/>
+              <a:t>First plan: 53 to add. The node group failed on t3.medium (not allowed on the free plan), so I switched to t3.small and applied again</a:t>
+            </a:r>
+            <a:endParaRPr lang="en-US" sz="1300" dirty="0"/>
+          </a:p>
+        </p:txBody>
+      </p:sp>
+      <p:sp>
+        <p:nvSpPr>
+          <p:cNvPr id="6" name="terraform plan output frame"/>
           <p:cNvSpPr/>
           <p:nvPr/>
         </p:nvSpPr>
         <p:spPr>
           <a:xfrm>
-            <a:off x="4352544" y="1152144"/>
-            <a:ext cx="4370832" cy="2520039"/>
+            <a:off x="420624" y="2249424"/>
+            <a:ext cx="4050792" cy="2337824"/>
           </a:xfrm>
           <a:prstGeom prst="roundRect">
             <a:avLst>
-              <a:gd name="adj" fmla="val 1814"/>
+              <a:gd name="adj" fmla="val 1956"/>
             </a:avLst>
           </a:prstGeom>
           <a:solidFill>
@@ -9318,7 +9748,7 @@
       </p:sp>
       <p:pic>
         <p:nvPicPr>
-          <p:cNvPr id="7" name="Image 0" descr="terraform validate and plan output">    </p:cNvPr>
+          <p:cNvPr id="7" name="Image 0" descr="terraform plan output">    </p:cNvPr>
           <p:cNvPicPr>
             <a:picLocks noChangeAspect="1"/>
           </p:cNvPicPr>
@@ -9332,8 +9762,8 @@
         </p:blipFill>
         <p:spPr>
           <a:xfrm>
-            <a:off x="4389120" y="1188720"/>
-            <a:ext cx="4297680" cy="2446887"/>
+            <a:off x="457200" y="2286000"/>
+            <a:ext cx="3977640" cy="2264672"/>
           </a:xfrm>
           <a:prstGeom prst="rect">
             <a:avLst/>
@@ -9342,64 +9772,62 @@
       </p:pic>
       <p:sp>
         <p:nvSpPr>
-          <p:cNvPr id="8" name="Status note"/>
+          <p:cNvPr id="8" name="terraform apply output frame"/>
           <p:cNvSpPr/>
           <p:nvPr/>
         </p:nvSpPr>
         <p:spPr>
           <a:xfrm>
-            <a:off x="457200" y="4069080"/>
-            <a:ext cx="8229600" cy="548640"/>
+            <a:off x="4672584" y="2249424"/>
+            <a:ext cx="3826652" cy="2404872"/>
           </a:xfrm>
           <a:prstGeom prst="roundRect">
             <a:avLst>
-              <a:gd name="adj" fmla="val 13333"/>
+              <a:gd name="adj" fmla="val 1901"/>
             </a:avLst>
           </a:prstGeom>
           <a:solidFill>
-            <a:schemeClr val="accent2">
-              <a:alpha val="18000"/>
-            </a:schemeClr>
+            <a:schemeClr val="bg1"/>
           </a:solidFill>
-          <a:ln/>
-        </p:spPr>
-      </p:sp>
-      <p:sp>
-        <p:nvSpPr>
-          <p:cNvPr id="9" name="Text 6"/>
-          <p:cNvSpPr txBox="1"/>
-          <p:nvPr/>
-        </p:nvSpPr>
-        <p:spPr>
-          <a:xfrm>
-            <a:off x="594360" y="4069080"/>
-            <a:ext cx="7955280" cy="548640"/>
-          </a:xfrm>
-          <a:prstGeom prst="rect">
-            <a:avLst/>
-          </a:prstGeom>
-          <a:noFill/>
-          <a:ln/>
-        </p:spPr>
-        <p:txBody>
-          <a:bodyPr wrap="square" lIns="0" tIns="0" rIns="0" bIns="0" rtlCol="0" anchor="ctr"/>
-          <a:lstStyle/>
-          <a:p>
-            <a:pPr indent="0" marL="0">
-              <a:buNone/>
-            </a:pPr>
-            <a:r>
-              <a:rPr lang="en-US" sz="1200" dirty="0">
-                <a:solidFill>
-                  <a:schemeClr val="tx1"/>
-                </a:solidFill>
-              </a:rPr>
-              <a:t>Status: init, validate and plan are done. Apply, the AWS Console screenshots and destroy are added after the cluster is created, then destroyed to stop billing.</a:t>
-            </a:r>
-            <a:endParaRPr lang="en-US" sz="1200" dirty="0"/>
-          </a:p>
-        </p:txBody>
-      </p:sp>
+          <a:ln w="9525">
+            <a:solidFill>
+              <a:schemeClr val="accent6"/>
+            </a:solidFill>
+            <a:prstDash val="solid"/>
+          </a:ln>
+          <a:effectLst>
+            <a:outerShdw sx="100000" sy="100000" kx="0" ky="0" algn="bl" rotWithShape="0" blurRad="76200" dist="25400" dir="5400000">
+              <a:srgbClr val="000000">
+                <a:alpha val="18000"/>
+              </a:srgbClr>
+            </a:outerShdw>
+          </a:effectLst>
+        </p:spPr>
+      </p:sp>
+      <p:pic>
+        <p:nvPicPr>
+          <p:cNvPr id="9" name="Image 1" descr="terraform apply output">    </p:cNvPr>
+          <p:cNvPicPr>
+            <a:picLocks noChangeAspect="1"/>
+          </p:cNvPicPr>
+          <p:nvPr/>
+        </p:nvPicPr>
+        <p:blipFill>
+          <a:blip r:embed="rId2"/>
+          <a:stretch>
+            <a:fillRect/>
+          </a:stretch>
+        </p:blipFill>
+        <p:spPr>
+          <a:xfrm>
+            <a:off x="4709160" y="2286000"/>
+            <a:ext cx="3753500" cy="2331720"/>
+          </a:xfrm>
+          <a:prstGeom prst="rect">
+            <a:avLst/>
+          </a:prstGeom>
+        </p:spPr>
+      </p:pic>
       <p:sp>
         <p:nvSpPr>
           <p:cNvPr id="25" name="Slide Number Placeholder 0"/>

</xml_diff>

<commit_message>
Make the README plain, remove status notes, and rebuild the deck
</commit_message>
<xml_diff>
--- a/docs/PlaceTrack-Capstone.pptx
+++ b/docs/PlaceTrack-Capstone.pptx
@@ -122,27 +122,27 @@
   <p:extLst>
     <p:ext uri="{521415D9-36F7-43E2-AB2F-B90AF26B5E84}">
       <p14:sectionLst xmlns:p14="http://schemas.microsoft.com/office/powerpoint/2010/main">
-        <p14:section name="Intro" id="{53a977af-a372-00ed-a7b8-ae4abab7f58b}">
+        <p14:section name="Intro" id="{4cf8cc1c-15cb-4685-2213-f2cecb6c1a68}">
           <p14:sldIdLst>
             <p14:sldId id="256"/>
             <p14:sldId id="257"/>
           </p14:sldIdLst>
         </p14:section>
-        <p14:section name="App and tests" id="{13e714e7-7366-c560-61ff-c3f4f8faaa0f}">
+        <p14:section name="App and tests" id="{b315a135-ce3b-09e6-e4a0-0c55c82565c7}">
           <p14:sldIdLst>
             <p14:sldId id="258"/>
             <p14:sldId id="259"/>
             <p14:sldId id="260"/>
           </p14:sldIdLst>
         </p14:section>
-        <p14:section name="Containers and CI" id="{43e57819-cd90-b1b6-96bc-5838ce9c01b7}">
+        <p14:section name="Containers and CI" id="{79bea056-e1e2-6a29-acba-468ba5b294dd}">
           <p14:sldIdLst>
             <p14:sldId id="261"/>
             <p14:sldId id="262"/>
             <p14:sldId id="263"/>
           </p14:sldIdLst>
         </p14:section>
-        <p14:section name="Infrastructure" id="{0111f913-7920-e40a-971f-ac2b844aff6e}">
+        <p14:section name="Infrastructure" id="{73ea2442-eb2c-b75f-522d-b0dbeff96b71}">
           <p14:sldIdLst>
             <p14:sldId id="264"/>
             <p14:sldId id="265"/>
@@ -150,14 +150,14 @@
             <p14:sldId id="267"/>
           </p14:sldIdLst>
         </p14:section>
-        <p14:section name="Operations" id="{48b086d2-d5a3-208e-f5f3-f28d39d5e972}">
+        <p14:section name="Operations" id="{985206ae-813a-9821-7048-4a256289cbe7}">
           <p14:sldIdLst>
             <p14:sldId id="268"/>
             <p14:sldId id="269"/>
             <p14:sldId id="270"/>
           </p14:sldIdLst>
         </p14:section>
-        <p14:section name="Close" id="{3546357d-a158-75cd-2597-0aa50fe30d97}">
+        <p14:section name="Close" id="{8d4e89e0-f6be-dd8d-55e1-d3e24b1ef3fa}">
           <p14:sldIdLst>
             <p14:sldId id="271"/>
           </p14:sldIdLst>
@@ -1710,7 +1710,7 @@
           <a:p>
             <a:r>
               <a:rPr lang="en-US" dirty="0"/>
-              <a:t>The workflow runs on every push to main. It runs pytest, builds the frontend, builds both Docker images, scans them with Trivy, and only then pushes them to GitHub Container Registry, tagged with the commit SHA instead of latest. If a test fails or Trivy finds a fixable high or critical vulnerability, nothing is published. The actions are pinned to exact commits and only the image job can write packages. I have not pushed the repository yet, so I ran each of these steps locally; the live run link comes after the first push.</a:t>
+              <a:t>The workflow runs on every push to main. It runs pytest, builds the frontend, builds both Docker images, scans them with Trivy, and only then pushes them to GitHub Container Registry, tagged with the commit SHA instead of latest. If a test fails or Trivy finds a fixable high or critical vulnerability, nothing is published. The actions are pinned to exact commits and only the image job can write packages.</a:t>
             </a:r>
             <a:endParaRPr lang="en-US" dirty="0"/>
           </a:p>
@@ -6724,7 +6724,7 @@
                   <a:schemeClr val="accent1"/>
                 </a:solidFill>
               </a:rPr>
-              <a:t>Ten graded modules, one repository. Every screenshot is a real capture; the GitHub run and AWS apply evidence are added once they are run.</a:t>
+              <a:t>Ten graded modules, one repository. Every screenshot is a real capture.</a:t>
             </a:r>
             <a:endParaRPr lang="en-US" sz="1600" dirty="0"/>
           </a:p>
@@ -7790,7 +7790,7 @@
                 <a:ea typeface="Cambria" pitchFamily="34" charset="-122"/>
                 <a:cs typeface="Cambria" pitchFamily="34" charset="-120"/>
               </a:rPr>
-              <a:t>27</a:t>
+              <a:t>28</a:t>
             </a:r>
             <a:endParaRPr lang="en-US" sz="4800" dirty="0"/>
           </a:p>
@@ -7917,7 +7917,7 @@
         <p:spPr>
           <a:xfrm>
             <a:off x="420624" y="2386584"/>
-            <a:ext cx="4659761" cy="2313432"/>
+            <a:ext cx="4585008" cy="2313432"/>
           </a:xfrm>
           <a:prstGeom prst="roundRect">
             <a:avLst>
@@ -7959,7 +7959,7 @@
         <p:spPr>
           <a:xfrm>
             <a:off x="457200" y="2423160"/>
-            <a:ext cx="4586609" cy="2240280"/>
+            <a:ext cx="4511856" cy="2240280"/>
           </a:xfrm>
           <a:prstGeom prst="rect">
             <a:avLst/>
@@ -8997,66 +8997,6 @@
               <a:t>Actions pinned to commit SHAs; write access only on the image job</a:t>
             </a:r>
             <a:endParaRPr lang="en-US" sz="1500" dirty="0"/>
-          </a:p>
-        </p:txBody>
-      </p:sp>
-      <p:sp>
-        <p:nvSpPr>
-          <p:cNvPr id="20" name="Status note"/>
-          <p:cNvSpPr/>
-          <p:nvPr/>
-        </p:nvSpPr>
-        <p:spPr>
-          <a:xfrm>
-            <a:off x="457200" y="4023360"/>
-            <a:ext cx="8229600" cy="548640"/>
-          </a:xfrm>
-          <a:prstGeom prst="roundRect">
-            <a:avLst>
-              <a:gd name="adj" fmla="val 13333"/>
-            </a:avLst>
-          </a:prstGeom>
-          <a:solidFill>
-            <a:schemeClr val="accent2">
-              <a:alpha val="18000"/>
-            </a:schemeClr>
-          </a:solidFill>
-          <a:ln/>
-        </p:spPr>
-      </p:sp>
-      <p:sp>
-        <p:nvSpPr>
-          <p:cNvPr id="21" name="Text 19"/>
-          <p:cNvSpPr txBox="1"/>
-          <p:nvPr/>
-        </p:nvSpPr>
-        <p:spPr>
-          <a:xfrm>
-            <a:off x="594360" y="4023360"/>
-            <a:ext cx="7955280" cy="548640"/>
-          </a:xfrm>
-          <a:prstGeom prst="rect">
-            <a:avLst/>
-          </a:prstGeom>
-          <a:noFill/>
-          <a:ln/>
-        </p:spPr>
-        <p:txBody>
-          <a:bodyPr wrap="square" lIns="0" tIns="0" rIns="0" bIns="0" rtlCol="0" anchor="ctr"/>
-          <a:lstStyle/>
-          <a:p>
-            <a:pPr indent="0" marL="0">
-              <a:buNone/>
-            </a:pPr>
-            <a:r>
-              <a:rPr lang="en-US" sz="1200" dirty="0">
-                <a:solidFill>
-                  <a:schemeClr val="tx1"/>
-                </a:solidFill>
-              </a:rPr>
-              <a:t>Status: every step was run locally (pytest, build, Docker, Trivy, Gitleaks). Nothing is pushed yet, so the Actions run link and GHCR page get added after the first push.</a:t>
-            </a:r>
-            <a:endParaRPr lang="en-US" sz="1200" dirty="0"/>
           </a:p>
         </p:txBody>
       </p:sp>

</xml_diff>

<commit_message>
Fix spacing and wording in the deck and clean the file properties
</commit_message>
<xml_diff>
--- a/docs/PlaceTrack-Capstone.pptx
+++ b/docs/PlaceTrack-Capstone.pptx
@@ -1270,7 +1270,7 @@
           <a:p>
             <a:r>
               <a:rPr lang="en-US" dirty="0"/>
-              <a:t>PlaceTrack lets me track every job application. Code goes through GitHub Actions for tests, builds and a security scan, images go to a registry tagged with the commit, Terraform builds the AWS network and cluster, Helm deploys, and Prometheus and Grafana watch it. Every screenshot in this deck is a real capture.</a:t>
+              <a:t>PlaceTrack lets me track every job application. Code goes through GitHub Actions for tests, builds and a security scan, images go to a registry tagged with the commit, Terraform builds the AWS network and cluster, Helm deploys, and Prometheus and Grafana watch it. All screenshots in this deck are from my own runs.</a:t>
             </a:r>
             <a:endParaRPr lang="en-US" dirty="0"/>
           </a:p>
@@ -4648,8 +4648,8 @@
         </p:nvSpPr>
         <p:spPr>
           <a:xfrm>
-            <a:off x="1280160" y="365760"/>
-            <a:ext cx="7406640" cy="566928"/>
+            <a:off x="1417320" y="365760"/>
+            <a:ext cx="7269480" cy="566928"/>
           </a:xfrm>
           <a:prstGeom prst="rect">
             <a:avLst/>
@@ -5376,7 +5376,7 @@
       </p:sp>
       <p:sp>
         <p:nvSpPr>
-          <p:cNvPr id="25" name="Text 23"/>
+          <p:cNvPr id="26" name="Text 23"/>
           <p:cNvSpPr txBox="1"/>
           <p:nvPr/>
         </p:nvSpPr>
@@ -6076,7 +6076,7 @@
                   <a:schemeClr val="tx1"/>
                 </a:solidFill>
               </a:rPr>
-              <a:t>PlaceTrack tracks job applications through applied, interview, offer and rejected. Every change travels the same path:</a:t>
+              <a:t>PlaceTrack tracks job applications through applied, interview, offer and rejected. Every change goes through these steps:</a:t>
             </a:r>
             <a:endParaRPr lang="en-US" sz="1600" dirty="0"/>
           </a:p>
@@ -6724,7 +6724,7 @@
                   <a:schemeClr val="accent1"/>
                 </a:solidFill>
               </a:rPr>
-              <a:t>Ten graded modules, one repository. Every screenshot is a real capture.</a:t>
+              <a:t>All screenshots in this deck are from my own runs.</a:t>
             </a:r>
             <a:endParaRPr lang="en-US" sz="1600" dirty="0"/>
           </a:p>
@@ -7020,7 +7020,7 @@
         </p:nvSpPr>
         <p:spPr>
           <a:xfrm>
-            <a:off x="7315200" y="1188720"/>
+            <a:off x="7315200" y="1051560"/>
             <a:ext cx="1463040" cy="731520"/>
           </a:xfrm>
           <a:prstGeom prst="rect">
@@ -7059,8 +7059,8 @@
         </p:nvSpPr>
         <p:spPr>
           <a:xfrm>
-            <a:off x="7315200" y="1920240"/>
-            <a:ext cx="1463040" cy="457200"/>
+            <a:off x="7315200" y="1737360"/>
+            <a:ext cx="1463040" cy="1005840"/>
           </a:xfrm>
           <a:prstGeom prst="rect">
             <a:avLst/>
@@ -7095,7 +7095,7 @@
         </p:nvSpPr>
         <p:spPr>
           <a:xfrm>
-            <a:off x="7315200" y="2651760"/>
+            <a:off x="7315200" y="2834640"/>
             <a:ext cx="1463040" cy="731520"/>
           </a:xfrm>
           <a:prstGeom prst="rect">
@@ -7134,8 +7134,8 @@
         </p:nvSpPr>
         <p:spPr>
           <a:xfrm>
-            <a:off x="7315200" y="3383280"/>
-            <a:ext cx="1463040" cy="457200"/>
+            <a:off x="7315200" y="3520440"/>
+            <a:ext cx="1463040" cy="685800"/>
           </a:xfrm>
           <a:prstGeom prst="rect">
             <a:avLst/>
@@ -7826,7 +7826,7 @@
                   <a:schemeClr val="accent6"/>
                 </a:solidFill>
               </a:rPr>
-              <a:t>meaningful commits so far</a:t>
+              <a:t>commits in the log below</a:t>
             </a:r>
             <a:endParaRPr lang="en-US" sz="1400" dirty="0"/>
           </a:p>

</xml_diff>

<commit_message>
Add a pipeline and GHCR slide to the deck
</commit_message>
<xml_diff>
--- a/docs/PlaceTrack-Capstone.pptx
+++ b/docs/PlaceTrack-Capstone.pptx
@@ -12,6 +12,7 @@
     <p:sldId id="260" r:id="rId6"/>
     <p:sldId id="261" r:id="rId7"/>
     <p:sldId id="262" r:id="rId8"/>
+    <p:sldId id="272" r:id="rId23"/>
     <p:sldId id="263" r:id="rId9"/>
     <p:sldId id="264" r:id="rId10"/>
     <p:sldId id="265" r:id="rId11"/>
@@ -677,7 +678,7 @@
           <a:p>
             <a:fld id="{F7021451-1387-4CA6-816F-3879F97B5CBC}" type="slidenum">
               <a:rPr lang="en-US"/>
-              <a:t>10</a:t>
+              <a:t>11</a:t>
             </a:fld>
             <a:endParaRPr lang="en-US"/>
           </a:p>
@@ -765,7 +766,7 @@
           <a:p>
             <a:fld id="{F7021451-1387-4CA6-816F-3879F97B5CBC}" type="slidenum">
               <a:rPr lang="en-US"/>
-              <a:t>11</a:t>
+              <a:t>12</a:t>
             </a:fld>
             <a:endParaRPr lang="en-US"/>
           </a:p>
@@ -853,7 +854,7 @@
           <a:p>
             <a:fld id="{F7021451-1387-4CA6-816F-3879F97B5CBC}" type="slidenum">
               <a:rPr lang="en-US"/>
-              <a:t>12</a:t>
+              <a:t>13</a:t>
             </a:fld>
             <a:endParaRPr lang="en-US"/>
           </a:p>
@@ -941,7 +942,7 @@
           <a:p>
             <a:fld id="{F7021451-1387-4CA6-816F-3879F97B5CBC}" type="slidenum">
               <a:rPr lang="en-US"/>
-              <a:t>13</a:t>
+              <a:t>14</a:t>
             </a:fld>
             <a:endParaRPr lang="en-US"/>
           </a:p>
@@ -1029,7 +1030,7 @@
           <a:p>
             <a:fld id="{F7021451-1387-4CA6-816F-3879F97B5CBC}" type="slidenum">
               <a:rPr lang="en-US"/>
-              <a:t>14</a:t>
+              <a:t>15</a:t>
             </a:fld>
             <a:endParaRPr lang="en-US"/>
           </a:p>
@@ -1117,7 +1118,7 @@
           <a:p>
             <a:fld id="{F7021451-1387-4CA6-816F-3879F97B5CBC}" type="slidenum">
               <a:rPr lang="en-US"/>
-              <a:t>15</a:t>
+              <a:t>16</a:t>
             </a:fld>
             <a:endParaRPr lang="en-US"/>
           </a:p>
@@ -1205,7 +1206,95 @@
           <a:p>
             <a:fld id="{F7021451-1387-4CA6-816F-3879F97B5CBC}" type="slidenum">
               <a:rPr lang="en-US"/>
-              <a:t>16</a:t>
+              <a:t>17</a:t>
+            </a:fld>
+            <a:endParaRPr lang="en-US"/>
+          </a:p>
+        </p:txBody>
+      </p:sp>
+    </p:spTree>
+    <p:extLst>
+      <p:ext uri="{BB962C8B-B14F-4D97-AF65-F5344CB8AC3E}">
+        <p14:creationId xmlns:p14="http://schemas.microsoft.com/office/powerpoint/2010/main" val="1024086991"/>
+      </p:ext>
+    </p:extLst>
+  </p:cSld>
+  <p:clrMapOvr>
+    <a:masterClrMapping/>
+  </p:clrMapOvr>
+</p:notes>
+</file>
+
+<file path=ppt/notesSlides/notesSlide17.xml><?xml version="1.0" encoding="utf-8"?>
+<p:notes xmlns:a="http://schemas.openxmlformats.org/drawingml/2006/main" xmlns:r="http://schemas.openxmlformats.org/officeDocument/2006/relationships" xmlns:p="http://schemas.openxmlformats.org/presentationml/2006/main">
+  <p:cSld>
+    <p:spTree>
+      <p:nvGrpSpPr>
+        <p:cNvPr id="1" name=""/>
+        <p:cNvGrpSpPr/>
+        <p:nvPr/>
+      </p:nvGrpSpPr>
+      <p:grpSpPr>
+        <a:xfrm>
+          <a:off x="0" y="0"/>
+          <a:ext cx="0" cy="0"/>
+          <a:chOff x="0" y="0"/>
+          <a:chExt cx="0" cy="0"/>
+        </a:xfrm>
+      </p:grpSpPr>
+      <p:sp>
+        <p:nvSpPr>
+          <p:cNvPr id="2" name="Slide Image Placeholder 1"/>
+          <p:cNvSpPr>
+            <a:spLocks noGrp="1" noRot="1" noChangeAspect="1"/>
+          </p:cNvSpPr>
+          <p:nvPr>
+            <p:ph type="sldImg"/>
+          </p:nvPr>
+        </p:nvSpPr>
+        <p:spPr/>
+      </p:sp>
+      <p:sp>
+        <p:nvSpPr>
+          <p:cNvPr id="3" name="Notes Placeholder 2"/>
+          <p:cNvSpPr>
+            <a:spLocks noGrp="1"/>
+          </p:cNvSpPr>
+          <p:nvPr>
+            <p:ph type="body" idx="1"/>
+          </p:nvPr>
+        </p:nvSpPr>
+        <p:spPr/>
+        <p:txBody>
+          <a:bodyPr/>
+          <a:lstStyle/>
+          <a:p>
+            <a:r>
+              <a:rPr lang="en-US" dirty="0"/>
+              <a:t>This is the first run of the pipeline on GitHub. All four jobs passed: the tests, the frontend build, and the backend and frontend images, each one built, scanned by Trivy and pushed. On the right are the two images in GitHub Container Registry. They are public and tagged with the commit SHA instead of latest, so every image can be traced back to the exact commit.</a:t>
+            </a:r>
+            <a:endParaRPr lang="en-US" dirty="0"/>
+          </a:p>
+        </p:txBody>
+      </p:sp>
+      <p:sp>
+        <p:nvSpPr>
+          <p:cNvPr id="4" name="Slide Number Placeholder 3"/>
+          <p:cNvSpPr>
+            <a:spLocks noGrp="1"/>
+          </p:cNvSpPr>
+          <p:nvPr>
+            <p:ph type="sldNum" sz="quarter" idx="10"/>
+          </p:nvPr>
+        </p:nvSpPr>
+        <p:spPr/>
+        <p:txBody>
+          <a:bodyPr/>
+          <a:lstStyle/>
+          <a:p>
+            <a:fld id="{F7021451-1387-4CA6-816F-3879F97B5CBC}" type="slidenum">
+              <a:rPr lang="en-US"/>
+              <a:t>8</a:t>
             </a:fld>
             <a:endParaRPr lang="en-US"/>
           </a:p>
@@ -1821,7 +1910,7 @@
           <a:p>
             <a:fld id="{F7021451-1387-4CA6-816F-3879F97B5CBC}" type="slidenum">
               <a:rPr lang="en-US"/>
-              <a:t>8</a:t>
+              <a:t>9</a:t>
             </a:fld>
             <a:endParaRPr lang="en-US"/>
           </a:p>
@@ -1909,7 +1998,7 @@
           <a:p>
             <a:fld id="{F7021451-1387-4CA6-816F-3879F97B5CBC}" type="slidenum">
               <a:rPr lang="en-US"/>
-              <a:t>9</a:t>
+              <a:t>10</a:t>
             </a:fld>
             <a:endParaRPr lang="en-US"/>
           </a:p>
@@ -3051,7 +3140,7 @@
             <a:pPr algn="l"/>
             <a:fld id="{F7021451-1387-4CA6-816F-3879F97B5CBC}" type="slidenum">
               <a:rPr b="0" lang="en-US"/>
-              <a:t>10</a:t>
+              <a:t>11</a:t>
             </a:fld>
             <a:endParaRPr lang="en-US"/>
           </a:p>
@@ -3333,7 +3422,7 @@
             <a:pPr algn="l"/>
             <a:fld id="{F7021451-1387-4CA6-816F-3879F97B5CBC}" type="slidenum">
               <a:rPr b="0" lang="en-US"/>
-              <a:t>11</a:t>
+              <a:t>12</a:t>
             </a:fld>
             <a:endParaRPr lang="en-US"/>
           </a:p>
@@ -3633,7 +3722,7 @@
             <a:pPr algn="l"/>
             <a:fld id="{F7021451-1387-4CA6-816F-3879F97B5CBC}" type="slidenum">
               <a:rPr b="0" lang="en-US"/>
-              <a:t>12</a:t>
+              <a:t>13</a:t>
             </a:fld>
             <a:endParaRPr lang="en-US"/>
           </a:p>
@@ -3973,7 +4062,7 @@
             <a:pPr algn="l"/>
             <a:fld id="{F7021451-1387-4CA6-816F-3879F97B5CBC}" type="slidenum">
               <a:rPr b="0" lang="en-US"/>
-              <a:t>13</a:t>
+              <a:t>14</a:t>
             </a:fld>
             <a:endParaRPr lang="en-US"/>
           </a:p>
@@ -4607,7 +4696,7 @@
             <a:pPr algn="l"/>
             <a:fld id="{F7021451-1387-4CA6-816F-3879F97B5CBC}" type="slidenum">
               <a:rPr b="0" lang="en-US"/>
-              <a:t>14</a:t>
+              <a:t>15</a:t>
             </a:fld>
             <a:endParaRPr lang="en-US"/>
           </a:p>
@@ -5449,7 +5538,7 @@
             <a:pPr algn="l"/>
             <a:fld id="{F7021451-1387-4CA6-816F-3879F97B5CBC}" type="slidenum">
               <a:rPr b="0" lang="en-US"/>
-              <a:t>15</a:t>
+              <a:t>16</a:t>
             </a:fld>
             <a:endParaRPr lang="en-US"/>
           </a:p>
@@ -5933,6 +6022,404 @@
 </p:sld>
 </file>
 
+<file path=ppt/slides/slide17.xml><?xml version="1.0" encoding="utf-8"?>
+<p:sld xmlns:a="http://schemas.openxmlformats.org/drawingml/2006/main" xmlns:r="http://schemas.openxmlformats.org/officeDocument/2006/relationships" xmlns:p="http://schemas.openxmlformats.org/presentationml/2006/main">
+  <p:cSld name="Slide 13">
+    <p:spTree>
+      <p:nvGrpSpPr>
+        <p:cNvPr id="1" name=""/>
+        <p:cNvGrpSpPr/>
+        <p:nvPr/>
+      </p:nvGrpSpPr>
+      <p:grpSpPr>
+        <a:xfrm>
+          <a:off x="0" y="0"/>
+          <a:ext cx="0" cy="0"/>
+          <a:chOff x="0" y="0"/>
+          <a:chExt cx="0" cy="0"/>
+        </a:xfrm>
+      </p:grpSpPr>
+      <p:sp>
+        <p:nvSpPr>
+          <p:cNvPr id="2" name="Text 1"/>
+          <p:cNvSpPr/>
+          <p:nvPr>
+            <p:ph idx="101" type="title" hasCustomPrompt="1"/>
+          </p:nvPr>
+        </p:nvSpPr>
+        <p:spPr>
+          <a:xfrm>
+            <a:off x="1280160" y="365760"/>
+            <a:ext cx="7406640" cy="566928"/>
+          </a:xfrm>
+          <a:prstGeom prst="rect">
+            <a:avLst/>
+          </a:prstGeom>
+          <a:noFill/>
+          <a:ln/>
+        </p:spPr>
+        <p:txBody>
+          <a:bodyPr wrap="square" lIns="0" tIns="0" rIns="0" bIns="0" rtlCol="0" anchor="ctr"/>
+          <a:lstStyle/>
+          <a:p>
+            <a:pPr algn="l" indent="0" marL="0">
+              <a:buNone/>
+            </a:pPr>
+            <a:r>
+              <a:rPr lang="en-US" sz="3200" b="1" dirty="0">
+                <a:solidFill>
+                  <a:schemeClr val="tx1"/>
+                </a:solidFill>
+              </a:rPr>
+              <a:t>Pipeline run and GHCR</a:t>
+            </a:r>
+            <a:endParaRPr lang="en-US" sz="3200" dirty="0"/>
+          </a:p>
+        </p:txBody>
+      </p:sp>
+      <p:sp>
+        <p:nvSpPr>
+          <p:cNvPr id="3" name="Module chip"/>
+          <p:cNvSpPr/>
+          <p:nvPr/>
+        </p:nvSpPr>
+        <p:spPr>
+          <a:xfrm>
+            <a:off x="457200" y="420624"/>
+            <a:ext cx="640080" cy="457200"/>
+          </a:xfrm>
+          <a:prstGeom prst="roundRect">
+            <a:avLst>
+              <a:gd name="adj" fmla="val 20000"/>
+            </a:avLst>
+          </a:prstGeom>
+          <a:solidFill>
+            <a:schemeClr val="accent1"/>
+          </a:solidFill>
+          <a:ln/>
+        </p:spPr>
+      </p:sp>
+      <p:sp>
+        <p:nvSpPr>
+          <p:cNvPr id="4" name="Text 2"/>
+          <p:cNvSpPr txBox="1"/>
+          <p:nvPr/>
+        </p:nvSpPr>
+        <p:spPr>
+          <a:xfrm>
+            <a:off x="457200" y="420624"/>
+            <a:ext cx="640080" cy="457200"/>
+          </a:xfrm>
+          <a:prstGeom prst="rect">
+            <a:avLst/>
+          </a:prstGeom>
+          <a:noFill/>
+          <a:ln/>
+        </p:spPr>
+        <p:txBody>
+          <a:bodyPr wrap="square" lIns="0" tIns="0" rIns="0" bIns="0" rtlCol="0" anchor="ctr"/>
+          <a:lstStyle/>
+          <a:p>
+            <a:pPr algn="ctr" indent="0" marL="0">
+              <a:buNone/>
+            </a:pPr>
+            <a:r>
+              <a:rPr lang="en-US" sz="1400" b="1" dirty="0">
+                <a:solidFill>
+                  <a:schemeClr val="bg1"/>
+                </a:solidFill>
+              </a:rPr>
+              <a:t>M5</a:t>
+            </a:r>
+            <a:endParaRPr lang="en-US" sz="1400" dirty="0"/>
+          </a:p>
+        </p:txBody>
+      </p:sp>
+      <p:sp>
+        <p:nvSpPr>
+          <p:cNvPr id="5" name="Actions run frame"/>
+          <p:cNvSpPr/>
+          <p:nvPr/>
+        </p:nvSpPr>
+        <p:spPr>
+          <a:xfrm>
+            <a:off x="420624" y="1064260"/>
+            <a:ext cx="4462272" cy="2816352"/>
+          </a:xfrm>
+          <a:prstGeom prst="roundRect">
+            <a:avLst>
+              <a:gd name="adj" fmla="val 1787"/>
+            </a:avLst>
+          </a:prstGeom>
+          <a:solidFill>
+            <a:schemeClr val="bg1"/>
+          </a:solidFill>
+          <a:ln w="9525">
+            <a:solidFill>
+              <a:schemeClr val="accent6"/>
+            </a:solidFill>
+            <a:prstDash val="solid"/>
+          </a:ln>
+          <a:effectLst>
+            <a:outerShdw sx="100000" sy="100000" kx="0" ky="0" algn="bl" rotWithShape="0" blurRad="76200" dist="25400" dir="5400000">
+              <a:srgbClr val="000000">
+                <a:alpha val="18000"/>
+              </a:srgbClr>
+            </a:outerShdw>
+          </a:effectLst>
+        </p:spPr>
+      </p:sp>
+      <p:pic>
+        <p:nvPicPr>
+          <p:cNvPr id="6" name="Image 0" descr="GitHub Actions run 1, all four jobs green">    </p:cNvPr>
+          <p:cNvPicPr>
+            <a:picLocks noChangeAspect="1"/>
+          </p:cNvPicPr>
+          <p:nvPr/>
+        </p:nvPicPr>
+        <p:blipFill>
+          <a:blip r:embed="rId1"/>
+          <a:stretch>
+            <a:fillRect/>
+          </a:stretch>
+        </p:blipFill>
+        <p:spPr>
+          <a:xfrm>
+            <a:off x="457200" y="1100836"/>
+            <a:ext cx="4389120" cy="2743200"/>
+          </a:xfrm>
+          <a:prstGeom prst="rect">
+            <a:avLst/>
+          </a:prstGeom>
+        </p:spPr>
+      </p:pic>
+      <p:sp>
+        <p:nvSpPr>
+          <p:cNvPr id="7" name="GHCR backend frame"/>
+          <p:cNvSpPr/>
+          <p:nvPr/>
+        </p:nvSpPr>
+        <p:spPr>
+          <a:xfrm>
+            <a:off x="5120640" y="1060704"/>
+            <a:ext cx="3602736" cy="1347724"/>
+          </a:xfrm>
+          <a:prstGeom prst="roundRect">
+            <a:avLst>
+              <a:gd name="adj" fmla="val 1787"/>
+            </a:avLst>
+          </a:prstGeom>
+          <a:solidFill>
+            <a:schemeClr val="bg1"/>
+          </a:solidFill>
+          <a:ln w="9525">
+            <a:solidFill>
+              <a:schemeClr val="accent6"/>
+            </a:solidFill>
+            <a:prstDash val="solid"/>
+          </a:ln>
+          <a:effectLst>
+            <a:outerShdw sx="100000" sy="100000" kx="0" ky="0" algn="bl" rotWithShape="0" blurRad="76200" dist="25400" dir="5400000">
+              <a:srgbClr val="000000">
+                <a:alpha val="18000"/>
+              </a:srgbClr>
+            </a:outerShdw>
+          </a:effectLst>
+        </p:spPr>
+      </p:sp>
+      <p:pic>
+        <p:nvPicPr>
+          <p:cNvPr id="8" name="Image 1" descr="GHCR page for placetrack-backend with the commit SHA tag">    </p:cNvPr>
+          <p:cNvPicPr>
+            <a:picLocks noChangeAspect="1"/>
+          </p:cNvPicPr>
+          <p:nvPr/>
+        </p:nvPicPr>
+        <p:blipFill>
+          <a:blip r:embed="rId2"/>
+          <a:stretch>
+            <a:fillRect/>
+          </a:stretch>
+        </p:blipFill>
+        <p:spPr>
+          <a:xfrm>
+            <a:off x="5157216" y="1097280"/>
+            <a:ext cx="3529584" cy="1274572"/>
+          </a:xfrm>
+          <a:prstGeom prst="rect">
+            <a:avLst/>
+          </a:prstGeom>
+        </p:spPr>
+      </p:pic>
+      <p:sp>
+        <p:nvSpPr>
+          <p:cNvPr id="20" name="GHCR frontend frame"/>
+          <p:cNvSpPr/>
+          <p:nvPr/>
+        </p:nvSpPr>
+        <p:spPr>
+          <a:xfrm>
+            <a:off x="5120640" y="2536444"/>
+            <a:ext cx="3602736" cy="1347724"/>
+          </a:xfrm>
+          <a:prstGeom prst="roundRect">
+            <a:avLst>
+              <a:gd name="adj" fmla="val 1787"/>
+            </a:avLst>
+          </a:prstGeom>
+          <a:solidFill>
+            <a:schemeClr val="bg1"/>
+          </a:solidFill>
+          <a:ln w="9525">
+            <a:solidFill>
+              <a:schemeClr val="accent6"/>
+            </a:solidFill>
+            <a:prstDash val="solid"/>
+          </a:ln>
+          <a:effectLst>
+            <a:outerShdw sx="100000" sy="100000" kx="0" ky="0" algn="bl" rotWithShape="0" blurRad="76200" dist="25400" dir="5400000">
+              <a:srgbClr val="000000">
+                <a:alpha val="18000"/>
+              </a:srgbClr>
+            </a:outerShdw>
+          </a:effectLst>
+        </p:spPr>
+      </p:sp>
+      <p:pic>
+        <p:nvPicPr>
+          <p:cNvPr id="21" name="Image 2" descr="GHCR page for placetrack-frontend with the commit SHA tag">    </p:cNvPr>
+          <p:cNvPicPr>
+            <a:picLocks noChangeAspect="1"/>
+          </p:cNvPicPr>
+          <p:nvPr/>
+        </p:nvPicPr>
+        <p:blipFill>
+          <a:blip r:embed="rId5"/>
+          <a:stretch>
+            <a:fillRect/>
+          </a:stretch>
+        </p:blipFill>
+        <p:spPr>
+          <a:xfrm>
+            <a:off x="5157216" y="2573020"/>
+            <a:ext cx="3529584" cy="1274572"/>
+          </a:xfrm>
+          <a:prstGeom prst="rect">
+            <a:avLst/>
+          </a:prstGeom>
+        </p:spPr>
+      </p:pic>
+      <p:sp>
+        <p:nvSpPr>
+          <p:cNvPr id="9" name="Text 5"/>
+          <p:cNvSpPr txBox="1"/>
+          <p:nvPr/>
+        </p:nvSpPr>
+        <p:spPr>
+          <a:xfrm>
+            <a:off x="457200" y="4069080"/>
+            <a:ext cx="8229600" cy="640080"/>
+          </a:xfrm>
+          <a:prstGeom prst="rect">
+            <a:avLst/>
+          </a:prstGeom>
+          <a:noFill/>
+          <a:ln/>
+        </p:spPr>
+        <p:txBody>
+          <a:bodyPr wrap="square" lIns="0" tIns="0" rIns="0" bIns="0" rtlCol="0" anchor="t"/>
+          <a:lstStyle/>
+          <a:p>
+            <a:pPr marL="342900" indent="-342900">
+              <a:spcAft>
+                <a:spcPts val="800"/>
+              </a:spcAft>
+              <a:buSzPct val="100000"/>
+              <a:buChar char="•"/>
+            </a:pPr>
+            <a:r>
+              <a:rPr lang="en-US" sz="1400" dirty="0">
+                <a:solidFill>
+                  <a:schemeClr val="tx1"/>
+                </a:solidFill>
+              </a:rPr>
+              <a:t>First run on GitHub: tests, frontend build, both image builds and Trivy all passed</a:t>
+            </a:r>
+            <a:endParaRPr lang="en-US" sz="1400" dirty="0"/>
+          </a:p>
+          <a:p>
+            <a:pPr marL="342900" indent="-342900">
+              <a:spcAft>
+                <a:spcPts val="800"/>
+              </a:spcAft>
+              <a:buSzPct val="100000"/>
+              <a:buChar char="•"/>
+            </a:pPr>
+            <a:r>
+              <a:rPr lang="en-US" sz="1400" dirty="0">
+                <a:solidFill>
+                  <a:schemeClr val="tx1"/>
+                </a:solidFill>
+              </a:rPr>
+              <a:t>Both images are public in GHCR and tagged with the commit SHA</a:t>
+            </a:r>
+            <a:endParaRPr lang="en-US" sz="1400" dirty="0"/>
+          </a:p>
+        </p:txBody>
+      </p:sp>
+      <p:sp>
+        <p:nvSpPr>
+          <p:cNvPr id="25" name="Slide Number Placeholder 0"/>
+          <p:cNvSpPr>
+            <a:spLocks noGrp="1"/>
+          </p:cNvSpPr>
+          <p:nvPr>
+            <p:ph type="sldNum" sz="quarter" idx="4294967295"/>
+          </p:nvPr>
+        </p:nvSpPr>
+        <p:spPr>
+          <a:xfrm>
+            <a:off x="8229600" y="4773168"/>
+            <a:ext cx="457200" cy="274320"/>
+          </a:xfrm>
+          <a:prstGeom prst="rect">
+            <a:avLst/>
+          </a:prstGeom>
+          <a:extLst>
+            <a:ext uri="{C572A759-6A51-4108-AA02-DFA0A04FC94B}">
+              <ma14:wrappingTextBoxFlag xmlns:ma14="http://schemas.microsoft.com/office/mac/drawingml/2011/main" val="0"/>
+            </a:ext>
+          </a:extLst>
+        </p:spPr>
+        <p:txBody>
+          <a:bodyPr/>
+          <a:lstStyle>
+            <a:lvl1pPr>
+              <a:defRPr sz="1000">
+                <a:solidFill>
+                  <a:schemeClr val="accent6"/>
+                </a:solidFill>
+              </a:defRPr>
+            </a:lvl1pPr>
+          </a:lstStyle>
+          <a:p>
+            <a:pPr algn="l"/>
+            <a:fld id="{F7021451-1387-4CA6-816F-3879F97B5CBC}" type="slidenum">
+              <a:rPr b="0" lang="en-US"/>
+              <a:t>8</a:t>
+            </a:fld>
+            <a:endParaRPr lang="en-US"/>
+          </a:p>
+        </p:txBody>
+      </p:sp>
+    </p:spTree>
+  </p:cSld>
+  <p:clrMapOvr>
+    <a:masterClrMapping/>
+  </p:clrMapOvr>
+</p:sld>
+</file>
+
 <file path=ppt/slides/slide2.xml><?xml version="1.0" encoding="utf-8"?>
 <p:sld xmlns:a="http://schemas.openxmlformats.org/drawingml/2006/main" xmlns:r="http://schemas.openxmlformats.org/officeDocument/2006/relationships" xmlns:p="http://schemas.openxmlformats.org/presentationml/2006/main">
   <p:cSld name="Slide 2">
@@ -9449,7 +9936,7 @@
             <a:pPr algn="l"/>
             <a:fld id="{F7021451-1387-4CA6-816F-3879F97B5CBC}" type="slidenum">
               <a:rPr b="0" lang="en-US"/>
-              <a:t>8</a:t>
+              <a:t>9</a:t>
             </a:fld>
             <a:endParaRPr lang="en-US"/>
           </a:p>
@@ -9807,7 +10294,7 @@
             <a:pPr algn="l"/>
             <a:fld id="{F7021451-1387-4CA6-816F-3879F97B5CBC}" type="slidenum">
               <a:rPr b="0" lang="en-US"/>
-              <a:t>9</a:t>
+              <a:t>10</a:t>
             </a:fld>
             <a:endParaRPr lang="en-US"/>
           </a:p>

</xml_diff>